<commit_message>
Update PowerShell presentation file for Intro to PowerShell at 2026 Day of Data - Raleigh
</commit_message>
<xml_diff>
--- a/Events/2026/DayofData - Raleigh/Intro to Powershell/Intro to Powershell.pptx
+++ b/Events/2026/DayofData - Raleigh/Intro to Powershell/Intro to Powershell.pptx
@@ -5,44 +5,43 @@
     <p:sldMasterId id="2147483648" r:id="rId1"/>
   </p:sldMasterIdLst>
   <p:notesMasterIdLst>
-    <p:notesMasterId r:id="rId27"/>
+    <p:notesMasterId r:id="rId26"/>
   </p:notesMasterIdLst>
   <p:sldIdLst>
     <p:sldId id="256" r:id="rId2"/>
-    <p:sldId id="286" r:id="rId3"/>
-    <p:sldId id="263" r:id="rId4"/>
-    <p:sldId id="264" r:id="rId5"/>
-    <p:sldId id="265" r:id="rId6"/>
-    <p:sldId id="266" r:id="rId7"/>
-    <p:sldId id="267" r:id="rId8"/>
-    <p:sldId id="268" r:id="rId9"/>
-    <p:sldId id="269" r:id="rId10"/>
-    <p:sldId id="270" r:id="rId11"/>
-    <p:sldId id="271" r:id="rId12"/>
-    <p:sldId id="272" r:id="rId13"/>
-    <p:sldId id="273" r:id="rId14"/>
-    <p:sldId id="274" r:id="rId15"/>
-    <p:sldId id="275" r:id="rId16"/>
-    <p:sldId id="276" r:id="rId17"/>
-    <p:sldId id="277" r:id="rId18"/>
-    <p:sldId id="278" r:id="rId19"/>
-    <p:sldId id="279" r:id="rId20"/>
-    <p:sldId id="280" r:id="rId21"/>
-    <p:sldId id="281" r:id="rId22"/>
-    <p:sldId id="282" r:id="rId23"/>
-    <p:sldId id="283" r:id="rId24"/>
-    <p:sldId id="284" r:id="rId25"/>
-    <p:sldId id="285" r:id="rId26"/>
+    <p:sldId id="263" r:id="rId3"/>
+    <p:sldId id="264" r:id="rId4"/>
+    <p:sldId id="265" r:id="rId5"/>
+    <p:sldId id="266" r:id="rId6"/>
+    <p:sldId id="267" r:id="rId7"/>
+    <p:sldId id="268" r:id="rId8"/>
+    <p:sldId id="269" r:id="rId9"/>
+    <p:sldId id="270" r:id="rId10"/>
+    <p:sldId id="271" r:id="rId11"/>
+    <p:sldId id="272" r:id="rId12"/>
+    <p:sldId id="273" r:id="rId13"/>
+    <p:sldId id="274" r:id="rId14"/>
+    <p:sldId id="275" r:id="rId15"/>
+    <p:sldId id="276" r:id="rId16"/>
+    <p:sldId id="277" r:id="rId17"/>
+    <p:sldId id="278" r:id="rId18"/>
+    <p:sldId id="279" r:id="rId19"/>
+    <p:sldId id="280" r:id="rId20"/>
+    <p:sldId id="281" r:id="rId21"/>
+    <p:sldId id="282" r:id="rId22"/>
+    <p:sldId id="283" r:id="rId23"/>
+    <p:sldId id="284" r:id="rId24"/>
+    <p:sldId id="285" r:id="rId25"/>
   </p:sldIdLst>
   <p:sldSz cx="12192000" cy="6858000"/>
   <p:notesSz cx="6858000" cy="9144000"/>
   <p:embeddedFontLst>
     <p:embeddedFont>
       <p:font typeface="Roboto" panose="02000000000000000000" pitchFamily="2" charset="0"/>
-      <p:regular r:id="rId28"/>
-      <p:bold r:id="rId29"/>
-      <p:italic r:id="rId30"/>
-      <p:boldItalic r:id="rId31"/>
+      <p:regular r:id="rId27"/>
+      <p:bold r:id="rId28"/>
+      <p:italic r:id="rId29"/>
+      <p:boldItalic r:id="rId30"/>
     </p:embeddedFont>
   </p:embeddedFontLst>
   <p:defaultTextStyle>
@@ -292,23 +291,70 @@
 </p:cmAuthorLst>
 </file>
 
-<file path=ppt/revisionInfo.xml><?xml version="1.0" encoding="utf-8"?>
-<p1510:revInfo xmlns:a="http://schemas.openxmlformats.org/drawingml/2006/main" xmlns:r="http://schemas.openxmlformats.org/officeDocument/2006/relationships" xmlns:p1510="http://schemas.microsoft.com/office/powerpoint/2015/10/main">
-  <p1510:revLst>
-    <p1510:client id="{33AFFC13-0A42-4349-B6D7-7A04302447D4}" v="1" dt="2026-05-13T16:24:08.460"/>
-  </p1510:revLst>
-</p1510:revInfo>
-</file>
-
 <file path=ppt/changesInfos/changesInfo1.xml><?xml version="1.0" encoding="utf-8"?>
 <pc:chgInfo xmlns:a="http://schemas.openxmlformats.org/drawingml/2006/main" xmlns:r="http://schemas.openxmlformats.org/officeDocument/2006/relationships" xmlns:ac="http://schemas.microsoft.com/office/drawing/2013/main/command" xmlns:pc="http://schemas.microsoft.com/office/powerpoint/2013/main/command">
   <pc:docChgLst>
     <pc:chgData name="Anthony (Tony) Wilhelm" userId="111808ec-cec1-4bb5-b99a-563afe69ab96" providerId="ADAL" clId="{72BD8168-86F3-43FC-B709-0507F7810D7D}"/>
     <pc:docChg chg="undo custSel addSld delSld modSld sldOrd delMainMaster">
-      <pc:chgData name="Anthony (Tony) Wilhelm" userId="111808ec-cec1-4bb5-b99a-563afe69ab96" providerId="ADAL" clId="{72BD8168-86F3-43FC-B709-0507F7810D7D}" dt="2026-05-13T16:24:28.268" v="231" actId="20577"/>
+      <pc:chgData name="Anthony (Tony) Wilhelm" userId="111808ec-cec1-4bb5-b99a-563afe69ab96" providerId="ADAL" clId="{72BD8168-86F3-43FC-B709-0507F7810D7D}" dt="2026-05-23T01:35:04.656" v="280" actId="1076"/>
       <pc:docMkLst>
         <pc:docMk/>
       </pc:docMkLst>
+      <pc:sldChg chg="addSp modSp mod">
+        <pc:chgData name="Anthony (Tony) Wilhelm" userId="111808ec-cec1-4bb5-b99a-563afe69ab96" providerId="ADAL" clId="{72BD8168-86F3-43FC-B709-0507F7810D7D}" dt="2026-05-23T01:35:04.656" v="280" actId="1076"/>
+        <pc:sldMkLst>
+          <pc:docMk/>
+          <pc:sldMk cId="0" sldId="263"/>
+        </pc:sldMkLst>
+        <pc:spChg chg="mod">
+          <ac:chgData name="Anthony (Tony) Wilhelm" userId="111808ec-cec1-4bb5-b99a-563afe69ab96" providerId="ADAL" clId="{72BD8168-86F3-43FC-B709-0507F7810D7D}" dt="2026-05-20T21:12:15.774" v="240" actId="1076"/>
+          <ac:spMkLst>
+            <pc:docMk/>
+            <pc:sldMk cId="0" sldId="263"/>
+            <ac:spMk id="140" creationId="{00000000-0000-0000-0000-000000000000}"/>
+          </ac:spMkLst>
+        </pc:spChg>
+        <pc:picChg chg="add mod">
+          <ac:chgData name="Anthony (Tony) Wilhelm" userId="111808ec-cec1-4bb5-b99a-563afe69ab96" providerId="ADAL" clId="{72BD8168-86F3-43FC-B709-0507F7810D7D}" dt="2026-05-23T01:34:58.614" v="279" actId="1076"/>
+          <ac:picMkLst>
+            <pc:docMk/>
+            <pc:sldMk cId="0" sldId="263"/>
+            <ac:picMk id="3" creationId="{231BA57F-A3D9-C256-0007-A0C9EB442804}"/>
+          </ac:picMkLst>
+        </pc:picChg>
+        <pc:picChg chg="mod">
+          <ac:chgData name="Anthony (Tony) Wilhelm" userId="111808ec-cec1-4bb5-b99a-563afe69ab96" providerId="ADAL" clId="{72BD8168-86F3-43FC-B709-0507F7810D7D}" dt="2026-05-23T01:35:04.656" v="280" actId="1076"/>
+          <ac:picMkLst>
+            <pc:docMk/>
+            <pc:sldMk cId="0" sldId="263"/>
+            <ac:picMk id="141" creationId="{00000000-0000-0000-0000-000000000000}"/>
+          </ac:picMkLst>
+        </pc:picChg>
+        <pc:picChg chg="mod">
+          <ac:chgData name="Anthony (Tony) Wilhelm" userId="111808ec-cec1-4bb5-b99a-563afe69ab96" providerId="ADAL" clId="{72BD8168-86F3-43FC-B709-0507F7810D7D}" dt="2026-05-20T21:12:15.774" v="240" actId="1076"/>
+          <ac:picMkLst>
+            <pc:docMk/>
+            <pc:sldMk cId="0" sldId="263"/>
+            <ac:picMk id="1026" creationId="{77A8FF47-810A-F7F2-B2E9-AFB6E362A2BC}"/>
+          </ac:picMkLst>
+        </pc:picChg>
+        <pc:picChg chg="mod">
+          <ac:chgData name="Anthony (Tony) Wilhelm" userId="111808ec-cec1-4bb5-b99a-563afe69ab96" providerId="ADAL" clId="{72BD8168-86F3-43FC-B709-0507F7810D7D}" dt="2026-05-20T21:12:15.774" v="240" actId="1076"/>
+          <ac:picMkLst>
+            <pc:docMk/>
+            <pc:sldMk cId="0" sldId="263"/>
+            <ac:picMk id="1030" creationId="{7C9BD6B7-44DA-5C3C-E60A-E46FD371FB12}"/>
+          </ac:picMkLst>
+        </pc:picChg>
+        <pc:picChg chg="mod">
+          <ac:chgData name="Anthony (Tony) Wilhelm" userId="111808ec-cec1-4bb5-b99a-563afe69ab96" providerId="ADAL" clId="{72BD8168-86F3-43FC-B709-0507F7810D7D}" dt="2026-05-20T21:12:15.774" v="240" actId="1076"/>
+          <ac:picMkLst>
+            <pc:docMk/>
+            <pc:sldMk cId="0" sldId="263"/>
+            <ac:picMk id="1032" creationId="{BF886A15-8696-37A6-4205-45F2E8AB5658}"/>
+          </ac:picMkLst>
+        </pc:picChg>
+      </pc:sldChg>
       <pc:sldChg chg="modSp mod">
         <pc:chgData name="Anthony (Tony) Wilhelm" userId="111808ec-cec1-4bb5-b99a-563afe69ab96" providerId="ADAL" clId="{72BD8168-86F3-43FC-B709-0507F7810D7D}" dt="2026-05-13T16:23:05.840" v="175" actId="20577"/>
         <pc:sldMkLst>
@@ -351,6 +397,21 @@
             <pc:docMk/>
             <pc:sldMk cId="0" sldId="272"/>
             <ac:spMk id="262" creationId="{00000000-0000-0000-0000-000000000000}"/>
+          </ac:spMkLst>
+        </pc:spChg>
+      </pc:sldChg>
+      <pc:sldChg chg="modSp mod">
+        <pc:chgData name="Anthony (Tony) Wilhelm" userId="111808ec-cec1-4bb5-b99a-563afe69ab96" providerId="ADAL" clId="{72BD8168-86F3-43FC-B709-0507F7810D7D}" dt="2026-05-20T21:13:14.950" v="269" actId="108"/>
+        <pc:sldMkLst>
+          <pc:docMk/>
+          <pc:sldMk cId="0" sldId="284"/>
+        </pc:sldMkLst>
+        <pc:spChg chg="mod">
+          <ac:chgData name="Anthony (Tony) Wilhelm" userId="111808ec-cec1-4bb5-b99a-563afe69ab96" providerId="ADAL" clId="{72BD8168-86F3-43FC-B709-0507F7810D7D}" dt="2026-05-20T21:13:14.950" v="269" actId="108"/>
+          <ac:spMkLst>
+            <pc:docMk/>
+            <pc:sldMk cId="0" sldId="284"/>
+            <ac:spMk id="384" creationId="{00000000-0000-0000-0000-000000000000}"/>
           </ac:spMkLst>
         </pc:spChg>
       </pc:sldChg>
@@ -2022,7 +2083,7 @@
             </a:pPr>
             <a:fld id="{00000000-1234-1234-1234-123412341234}" type="slidenum">
               <a:rPr lang="en-US"/>
-              <a:t>12</a:t>
+              <a:t>11</a:t>
             </a:fld>
             <a:endParaRPr/>
           </a:p>
@@ -2193,7 +2254,7 @@
             </a:pPr>
             <a:fld id="{00000000-1234-1234-1234-123412341234}" type="slidenum">
               <a:rPr lang="en-US"/>
-              <a:t>13</a:t>
+              <a:t>12</a:t>
             </a:fld>
             <a:endParaRPr/>
           </a:p>
@@ -2364,7 +2425,7 @@
             </a:pPr>
             <a:fld id="{00000000-1234-1234-1234-123412341234}" type="slidenum">
               <a:rPr lang="en-US"/>
-              <a:t>14</a:t>
+              <a:t>13</a:t>
             </a:fld>
             <a:endParaRPr/>
           </a:p>
@@ -2868,7 +2929,7 @@
             </a:pPr>
             <a:fld id="{00000000-1234-1234-1234-123412341234}" type="slidenum">
               <a:rPr lang="en-US"/>
-              <a:t>18</a:t>
+              <a:t>17</a:t>
             </a:fld>
             <a:endParaRPr/>
           </a:p>
@@ -3150,7 +3211,7 @@
             </a:pPr>
             <a:fld id="{00000000-1234-1234-1234-123412341234}" type="slidenum">
               <a:rPr lang="en-US"/>
-              <a:t>20</a:t>
+              <a:t>19</a:t>
             </a:fld>
             <a:endParaRPr/>
           </a:p>
@@ -3543,7 +3604,7 @@
             </a:pPr>
             <a:fld id="{00000000-1234-1234-1234-123412341234}" type="slidenum">
               <a:rPr lang="en-US"/>
-              <a:t>22</a:t>
+              <a:t>21</a:t>
             </a:fld>
             <a:endParaRPr/>
           </a:p>
@@ -3714,7 +3775,7 @@
             </a:pPr>
             <a:fld id="{00000000-1234-1234-1234-123412341234}" type="slidenum">
               <a:rPr lang="en-US"/>
-              <a:t>23</a:t>
+              <a:t>22</a:t>
             </a:fld>
             <a:endParaRPr/>
           </a:p>
@@ -3885,7 +3946,7 @@
             </a:pPr>
             <a:fld id="{00000000-1234-1234-1234-123412341234}" type="slidenum">
               <a:rPr lang="en-US"/>
-              <a:t>24</a:t>
+              <a:t>23</a:t>
             </a:fld>
             <a:endParaRPr/>
           </a:p>
@@ -4056,7 +4117,7 @@
             </a:pPr>
             <a:fld id="{00000000-1234-1234-1234-123412341234}" type="slidenum">
               <a:rPr lang="en-US"/>
-              <a:t>25</a:t>
+              <a:t>24</a:t>
             </a:fld>
             <a:endParaRPr/>
           </a:p>
@@ -4232,7 +4293,7 @@
             </a:pPr>
             <a:fld id="{00000000-1234-1234-1234-123412341234}" type="slidenum">
               <a:rPr lang="en-US"/>
-              <a:t>4</a:t>
+              <a:t>3</a:t>
             </a:fld>
             <a:endParaRPr/>
           </a:p>
@@ -4407,7 +4468,7 @@
             </a:pPr>
             <a:fld id="{00000000-1234-1234-1234-123412341234}" type="slidenum">
               <a:rPr lang="en-US"/>
-              <a:t>5</a:t>
+              <a:t>4</a:t>
             </a:fld>
             <a:endParaRPr/>
           </a:p>
@@ -4582,7 +4643,7 @@
             </a:pPr>
             <a:fld id="{00000000-1234-1234-1234-123412341234}" type="slidenum">
               <a:rPr lang="en-US"/>
-              <a:t>6</a:t>
+              <a:t>5</a:t>
             </a:fld>
             <a:endParaRPr/>
           </a:p>
@@ -4753,7 +4814,7 @@
             </a:pPr>
             <a:fld id="{00000000-1234-1234-1234-123412341234}" type="slidenum">
               <a:rPr lang="en-US"/>
-              <a:t>7</a:t>
+              <a:t>6</a:t>
             </a:fld>
             <a:endParaRPr/>
           </a:p>
@@ -5146,7 +5207,7 @@
             </a:pPr>
             <a:fld id="{00000000-1234-1234-1234-123412341234}" type="slidenum">
               <a:rPr lang="en-US"/>
-              <a:t>10</a:t>
+              <a:t>9</a:t>
             </a:fld>
             <a:endParaRPr/>
           </a:p>
@@ -15799,460 +15860,6 @@
     </p:bg>
     <p:spTree>
       <p:nvGrpSpPr>
-        <p:cNvPr id="1" name="Shape 237"/>
-        <p:cNvGrpSpPr/>
-        <p:nvPr/>
-      </p:nvGrpSpPr>
-      <p:grpSpPr>
-        <a:xfrm>
-          <a:off x="0" y="0"/>
-          <a:ext cx="0" cy="0"/>
-          <a:chOff x="0" y="0"/>
-          <a:chExt cx="0" cy="0"/>
-        </a:xfrm>
-      </p:grpSpPr>
-      <p:sp>
-        <p:nvSpPr>
-          <p:cNvPr id="238" name="Google Shape;238;p10"/>
-          <p:cNvSpPr/>
-          <p:nvPr/>
-        </p:nvSpPr>
-        <p:spPr>
-          <a:xfrm flipH="1">
-            <a:off x="-3" y="-1"/>
-            <a:ext cx="12192000" cy="1590600"/>
-          </a:xfrm>
-          <a:prstGeom prst="rect">
-            <a:avLst/>
-          </a:prstGeom>
-          <a:gradFill>
-            <a:gsLst>
-              <a:gs pos="0">
-                <a:srgbClr val="000000"/>
-              </a:gs>
-              <a:gs pos="100000">
-                <a:srgbClr val="2F5496"/>
-              </a:gs>
-            </a:gsLst>
-            <a:lin ang="8400134" scaled="0"/>
-          </a:gradFill>
-          <a:ln>
-            <a:noFill/>
-          </a:ln>
-        </p:spPr>
-        <p:txBody>
-          <a:bodyPr spcFirstLastPara="1" wrap="square" lIns="91425" tIns="45700" rIns="91425" bIns="45700" anchor="ctr" anchorCtr="0">
-            <a:noAutofit/>
-          </a:bodyPr>
-          <a:lstStyle/>
-          <a:p>
-            <a:pPr marL="0" marR="0" lvl="0" indent="0" algn="ctr" rtl="0">
-              <a:spcBef>
-                <a:spcPts val="0"/>
-              </a:spcBef>
-              <a:spcAft>
-                <a:spcPts val="0"/>
-              </a:spcAft>
-              <a:buNone/>
-            </a:pPr>
-            <a:endParaRPr sz="1800" b="0" i="0" u="none" strike="noStrike" cap="none">
-              <a:solidFill>
-                <a:schemeClr val="lt1"/>
-              </a:solidFill>
-              <a:latin typeface="Calibri"/>
-              <a:ea typeface="Calibri"/>
-              <a:cs typeface="Calibri"/>
-              <a:sym typeface="Calibri"/>
-            </a:endParaRPr>
-          </a:p>
-        </p:txBody>
-      </p:sp>
-      <p:sp>
-        <p:nvSpPr>
-          <p:cNvPr id="239" name="Google Shape;239;p10"/>
-          <p:cNvSpPr/>
-          <p:nvPr/>
-        </p:nvSpPr>
-        <p:spPr>
-          <a:xfrm rot="10800000" flipH="1">
-            <a:off x="-3" y="142"/>
-            <a:ext cx="8115300" cy="1590600"/>
-          </a:xfrm>
-          <a:prstGeom prst="rect">
-            <a:avLst/>
-          </a:prstGeom>
-          <a:gradFill>
-            <a:gsLst>
-              <a:gs pos="0">
-                <a:srgbClr val="4472C4">
-                  <a:alpha val="0"/>
-                </a:srgbClr>
-              </a:gs>
-              <a:gs pos="20000">
-                <a:srgbClr val="4472C4">
-                  <a:alpha val="0"/>
-                </a:srgbClr>
-              </a:gs>
-              <a:gs pos="100000">
-                <a:srgbClr val="1F3864">
-                  <a:alpha val="54901"/>
-                </a:srgbClr>
-              </a:gs>
-            </a:gsLst>
-            <a:lin ang="13800146" scaled="0"/>
-          </a:gradFill>
-          <a:ln>
-            <a:noFill/>
-          </a:ln>
-        </p:spPr>
-        <p:txBody>
-          <a:bodyPr spcFirstLastPara="1" wrap="square" lIns="91425" tIns="45700" rIns="91425" bIns="45700" anchor="ctr" anchorCtr="0">
-            <a:noAutofit/>
-          </a:bodyPr>
-          <a:lstStyle/>
-          <a:p>
-            <a:pPr marL="0" marR="0" lvl="0" indent="0" algn="ctr" rtl="0">
-              <a:spcBef>
-                <a:spcPts val="0"/>
-              </a:spcBef>
-              <a:spcAft>
-                <a:spcPts val="0"/>
-              </a:spcAft>
-              <a:buNone/>
-            </a:pPr>
-            <a:endParaRPr sz="1800" b="0" i="0" u="none" strike="noStrike" cap="none">
-              <a:solidFill>
-                <a:schemeClr val="lt1"/>
-              </a:solidFill>
-              <a:latin typeface="Calibri"/>
-              <a:ea typeface="Calibri"/>
-              <a:cs typeface="Calibri"/>
-              <a:sym typeface="Calibri"/>
-            </a:endParaRPr>
-          </a:p>
-        </p:txBody>
-      </p:sp>
-      <p:sp>
-        <p:nvSpPr>
-          <p:cNvPr id="240" name="Google Shape;240;p10"/>
-          <p:cNvSpPr txBox="1">
-            <a:spLocks noGrp="1"/>
-          </p:cNvSpPr>
-          <p:nvPr>
-            <p:ph type="title"/>
-          </p:nvPr>
-        </p:nvSpPr>
-        <p:spPr>
-          <a:xfrm>
-            <a:off x="1371597" y="348865"/>
-            <a:ext cx="10044000" cy="877800"/>
-          </a:xfrm>
-          <a:prstGeom prst="rect">
-            <a:avLst/>
-          </a:prstGeom>
-          <a:noFill/>
-          <a:ln>
-            <a:noFill/>
-          </a:ln>
-        </p:spPr>
-        <p:txBody>
-          <a:bodyPr spcFirstLastPara="1" wrap="square" lIns="91425" tIns="45700" rIns="91425" bIns="45700" anchor="ctr" anchorCtr="0">
-            <a:normAutofit/>
-          </a:bodyPr>
-          <a:lstStyle/>
-          <a:p>
-            <a:pPr marL="0" lvl="0" indent="0" algn="l" rtl="0">
-              <a:lnSpc>
-                <a:spcPct val="90000"/>
-              </a:lnSpc>
-              <a:spcBef>
-                <a:spcPts val="0"/>
-              </a:spcBef>
-              <a:spcAft>
-                <a:spcPts val="0"/>
-              </a:spcAft>
-              <a:buClr>
-                <a:srgbClr val="FFFFFF"/>
-              </a:buClr>
-              <a:buSzPts val="4000"/>
-              <a:buFont typeface="Calibri"/>
-              <a:buNone/>
-            </a:pPr>
-            <a:r>
-              <a:rPr lang="en-US" sz="4000">
-                <a:solidFill>
-                  <a:srgbClr val="FFFFFF"/>
-                </a:solidFill>
-                <a:latin typeface="Calibri"/>
-                <a:ea typeface="Calibri"/>
-                <a:cs typeface="Calibri"/>
-                <a:sym typeface="Calibri"/>
-              </a:rPr>
-              <a:t>Variables</a:t>
-            </a:r>
-            <a:endParaRPr/>
-          </a:p>
-        </p:txBody>
-      </p:sp>
-      <p:sp>
-        <p:nvSpPr>
-          <p:cNvPr id="241" name="Google Shape;241;p10"/>
-          <p:cNvSpPr txBox="1">
-            <a:spLocks noGrp="1"/>
-          </p:cNvSpPr>
-          <p:nvPr>
-            <p:ph type="body" idx="2"/>
-          </p:nvPr>
-        </p:nvSpPr>
-        <p:spPr>
-          <a:xfrm>
-            <a:off x="1166297" y="2112579"/>
-            <a:ext cx="4872919" cy="4089712"/>
-          </a:xfrm>
-          <a:prstGeom prst="rect">
-            <a:avLst/>
-          </a:prstGeom>
-          <a:noFill/>
-          <a:ln>
-            <a:noFill/>
-          </a:ln>
-        </p:spPr>
-        <p:txBody>
-          <a:bodyPr spcFirstLastPara="1" wrap="square" lIns="91425" tIns="45700" rIns="91425" bIns="45700" anchor="t" anchorCtr="0">
-            <a:normAutofit/>
-          </a:bodyPr>
-          <a:lstStyle/>
-          <a:p>
-            <a:pPr marL="212598" lvl="0" indent="-212343" algn="l" rtl="0">
-              <a:lnSpc>
-                <a:spcPct val="90000"/>
-              </a:lnSpc>
-              <a:spcBef>
-                <a:spcPts val="0"/>
-              </a:spcBef>
-              <a:spcAft>
-                <a:spcPts val="0"/>
-              </a:spcAft>
-              <a:buClr>
-                <a:schemeClr val="dk1"/>
-              </a:buClr>
-              <a:buSzPts val="2600"/>
-              <a:buChar char="•"/>
-            </a:pPr>
-            <a:r>
-              <a:rPr lang="en-US" sz="2600" dirty="0">
-                <a:solidFill>
-                  <a:schemeClr val="dk1"/>
-                </a:solidFill>
-                <a:latin typeface="Calibri"/>
-                <a:ea typeface="Calibri"/>
-                <a:cs typeface="Calibri"/>
-                <a:sym typeface="Calibri"/>
-              </a:rPr>
-              <a:t>Names start with a $</a:t>
-            </a:r>
-            <a:endParaRPr sz="2600" dirty="0"/>
-          </a:p>
-          <a:p>
-            <a:pPr marL="212598" lvl="0" indent="-212343" algn="l" rtl="0">
-              <a:lnSpc>
-                <a:spcPct val="90000"/>
-              </a:lnSpc>
-              <a:spcBef>
-                <a:spcPts val="930"/>
-              </a:spcBef>
-              <a:spcAft>
-                <a:spcPts val="0"/>
-              </a:spcAft>
-              <a:buClr>
-                <a:schemeClr val="dk1"/>
-              </a:buClr>
-              <a:buSzPts val="2600"/>
-              <a:buChar char="•"/>
-            </a:pPr>
-            <a:r>
-              <a:rPr lang="en-US" sz="2600" dirty="0">
-                <a:solidFill>
-                  <a:schemeClr val="dk1"/>
-                </a:solidFill>
-                <a:latin typeface="Calibri"/>
-                <a:ea typeface="Calibri"/>
-                <a:cs typeface="Calibri"/>
-                <a:sym typeface="Calibri"/>
-              </a:rPr>
-              <a:t>Names are not case sensitive</a:t>
-            </a:r>
-            <a:endParaRPr sz="2600" dirty="0"/>
-          </a:p>
-          <a:p>
-            <a:pPr marL="212598" lvl="0" indent="-212343" algn="l" rtl="0">
-              <a:lnSpc>
-                <a:spcPct val="90000"/>
-              </a:lnSpc>
-              <a:spcBef>
-                <a:spcPts val="930"/>
-              </a:spcBef>
-              <a:spcAft>
-                <a:spcPts val="0"/>
-              </a:spcAft>
-              <a:buClr>
-                <a:schemeClr val="dk1"/>
-              </a:buClr>
-              <a:buSzPts val="2600"/>
-              <a:buChar char="•"/>
-            </a:pPr>
-            <a:r>
-              <a:rPr lang="en-US" sz="2600" dirty="0">
-                <a:solidFill>
-                  <a:schemeClr val="dk1"/>
-                </a:solidFill>
-                <a:latin typeface="Calibri"/>
-                <a:ea typeface="Calibri"/>
-                <a:cs typeface="Calibri"/>
-                <a:sym typeface="Calibri"/>
-              </a:rPr>
-              <a:t>Can contain numbers and letters</a:t>
-            </a:r>
-            <a:endParaRPr sz="2600" dirty="0"/>
-          </a:p>
-          <a:p>
-            <a:pPr marL="212598" lvl="0" indent="-212343" algn="l" rtl="0">
-              <a:lnSpc>
-                <a:spcPct val="90000"/>
-              </a:lnSpc>
-              <a:spcBef>
-                <a:spcPts val="930"/>
-              </a:spcBef>
-              <a:spcAft>
-                <a:spcPts val="0"/>
-              </a:spcAft>
-              <a:buClr>
-                <a:schemeClr val="dk1"/>
-              </a:buClr>
-              <a:buSzPts val="2600"/>
-              <a:buChar char="•"/>
-            </a:pPr>
-            <a:r>
-              <a:rPr lang="en-US" sz="2600" dirty="0"/>
-              <a:t>Variables have multiple scopes:</a:t>
-            </a:r>
-            <a:endParaRPr sz="2600" dirty="0"/>
-          </a:p>
-          <a:p>
-            <a:pPr marL="669798" lvl="1" indent="-225298" algn="l" rtl="0">
-              <a:lnSpc>
-                <a:spcPct val="90000"/>
-              </a:lnSpc>
-              <a:spcBef>
-                <a:spcPts val="930"/>
-              </a:spcBef>
-              <a:spcAft>
-                <a:spcPts val="0"/>
-              </a:spcAft>
-              <a:buClr>
-                <a:schemeClr val="dk1"/>
-              </a:buClr>
-              <a:buSzPts val="2600"/>
-              <a:buChar char="•"/>
-            </a:pPr>
-            <a:r>
-              <a:rPr lang="en-US" sz="2600" dirty="0"/>
-              <a:t>Global</a:t>
-            </a:r>
-            <a:endParaRPr sz="2600" dirty="0"/>
-          </a:p>
-          <a:p>
-            <a:pPr marL="669798" lvl="1" indent="-225298" algn="l" rtl="0">
-              <a:lnSpc>
-                <a:spcPct val="90000"/>
-              </a:lnSpc>
-              <a:spcBef>
-                <a:spcPts val="930"/>
-              </a:spcBef>
-              <a:spcAft>
-                <a:spcPts val="0"/>
-              </a:spcAft>
-              <a:buClr>
-                <a:schemeClr val="dk1"/>
-              </a:buClr>
-              <a:buSzPts val="2600"/>
-              <a:buChar char="•"/>
-            </a:pPr>
-            <a:r>
-              <a:rPr lang="en-US" sz="2600" dirty="0"/>
-              <a:t>Local</a:t>
-            </a:r>
-            <a:endParaRPr sz="2600" dirty="0"/>
-          </a:p>
-          <a:p>
-            <a:pPr marL="669798" lvl="1" indent="-225298" algn="l" rtl="0">
-              <a:lnSpc>
-                <a:spcPct val="90000"/>
-              </a:lnSpc>
-              <a:spcBef>
-                <a:spcPts val="930"/>
-              </a:spcBef>
-              <a:spcAft>
-                <a:spcPts val="0"/>
-              </a:spcAft>
-              <a:buClr>
-                <a:schemeClr val="dk1"/>
-              </a:buClr>
-              <a:buSzPts val="2600"/>
-              <a:buChar char="•"/>
-            </a:pPr>
-            <a:r>
-              <a:rPr lang="en-US" sz="2600" dirty="0"/>
-              <a:t>Script</a:t>
-            </a:r>
-            <a:endParaRPr sz="2600" dirty="0"/>
-          </a:p>
-          <a:p>
-            <a:pPr marL="669798" lvl="1" indent="-225298" algn="l" rtl="0">
-              <a:lnSpc>
-                <a:spcPct val="90000"/>
-              </a:lnSpc>
-              <a:spcBef>
-                <a:spcPts val="930"/>
-              </a:spcBef>
-              <a:spcAft>
-                <a:spcPts val="0"/>
-              </a:spcAft>
-              <a:buClr>
-                <a:schemeClr val="dk1"/>
-              </a:buClr>
-              <a:buSzPts val="2600"/>
-              <a:buChar char="•"/>
-            </a:pPr>
-            <a:r>
-              <a:rPr lang="en-US" sz="2600" dirty="0"/>
-              <a:t>Private (not really a scope)</a:t>
-            </a:r>
-            <a:endParaRPr sz="2600" dirty="0"/>
-          </a:p>
-        </p:txBody>
-      </p:sp>
-    </p:spTree>
-  </p:cSld>
-  <p:clrMapOvr>
-    <a:masterClrMapping/>
-  </p:clrMapOvr>
-</p:sld>
-</file>
-
-<file path=ppt/slides/slide11.xml><?xml version="1.0" encoding="utf-8"?>
-<p:sld xmlns:a="http://schemas.openxmlformats.org/drawingml/2006/main" xmlns:r="http://schemas.openxmlformats.org/officeDocument/2006/relationships" xmlns:p="http://schemas.openxmlformats.org/presentationml/2006/main">
-  <p:cSld>
-    <p:bg>
-      <p:bgPr>
-        <a:solidFill>
-          <a:schemeClr val="lt1"/>
-        </a:solidFill>
-        <a:effectLst/>
-      </p:bgPr>
-    </p:bg>
-    <p:spTree>
-      <p:nvGrpSpPr>
         <p:cNvPr id="1" name="Shape 245"/>
         <p:cNvGrpSpPr/>
         <p:nvPr/>
@@ -16678,7 +16285,7 @@
 </p:sld>
 </file>
 
-<file path=ppt/slides/slide12.xml><?xml version="1.0" encoding="utf-8"?>
+<file path=ppt/slides/slide11.xml><?xml version="1.0" encoding="utf-8"?>
 <p:sld xmlns:a="http://schemas.openxmlformats.org/drawingml/2006/main" xmlns:r="http://schemas.openxmlformats.org/officeDocument/2006/relationships" xmlns:p="http://schemas.openxmlformats.org/presentationml/2006/main">
   <p:cSld>
     <p:bg>
@@ -17339,7 +16946,7 @@
 </p:sld>
 </file>
 
-<file path=ppt/slides/slide13.xml><?xml version="1.0" encoding="utf-8"?>
+<file path=ppt/slides/slide12.xml><?xml version="1.0" encoding="utf-8"?>
 <p:sld xmlns:a="http://schemas.openxmlformats.org/drawingml/2006/main" xmlns:r="http://schemas.openxmlformats.org/officeDocument/2006/relationships" xmlns:p="http://schemas.openxmlformats.org/presentationml/2006/main">
   <p:cSld>
     <p:bg>
@@ -18040,7 +17647,7 @@
 </p:sld>
 </file>
 
-<file path=ppt/slides/slide14.xml><?xml version="1.0" encoding="utf-8"?>
+<file path=ppt/slides/slide13.xml><?xml version="1.0" encoding="utf-8"?>
 <p:sld xmlns:a="http://schemas.openxmlformats.org/drawingml/2006/main" xmlns:r="http://schemas.openxmlformats.org/officeDocument/2006/relationships" xmlns:p="http://schemas.openxmlformats.org/presentationml/2006/main">
   <p:cSld>
     <p:bg>
@@ -18458,7 +18065,7 @@
 </p:sld>
 </file>
 
-<file path=ppt/slides/slide15.xml><?xml version="1.0" encoding="utf-8"?>
+<file path=ppt/slides/slide14.xml><?xml version="1.0" encoding="utf-8"?>
 <p:sld xmlns:a="http://schemas.openxmlformats.org/drawingml/2006/main" xmlns:r="http://schemas.openxmlformats.org/officeDocument/2006/relationships" xmlns:p="http://schemas.openxmlformats.org/presentationml/2006/main">
   <p:cSld>
     <p:bg>
@@ -18888,7 +18495,7 @@
 </p:sld>
 </file>
 
-<file path=ppt/slides/slide16.xml><?xml version="1.0" encoding="utf-8"?>
+<file path=ppt/slides/slide15.xml><?xml version="1.0" encoding="utf-8"?>
 <p:sld xmlns:a="http://schemas.openxmlformats.org/drawingml/2006/main" xmlns:r="http://schemas.openxmlformats.org/officeDocument/2006/relationships" xmlns:p="http://schemas.openxmlformats.org/presentationml/2006/main">
   <p:cSld>
     <p:bg>
@@ -19328,7 +18935,7 @@
 </p:sld>
 </file>
 
-<file path=ppt/slides/slide17.xml><?xml version="1.0" encoding="utf-8"?>
+<file path=ppt/slides/slide16.xml><?xml version="1.0" encoding="utf-8"?>
 <p:sld xmlns:a="http://schemas.openxmlformats.org/drawingml/2006/main" xmlns:r="http://schemas.openxmlformats.org/officeDocument/2006/relationships" xmlns:p="http://schemas.openxmlformats.org/presentationml/2006/main">
   <p:cSld>
     <p:bg>
@@ -19681,7 +19288,7 @@
 </p:sld>
 </file>
 
-<file path=ppt/slides/slide18.xml><?xml version="1.0" encoding="utf-8"?>
+<file path=ppt/slides/slide17.xml><?xml version="1.0" encoding="utf-8"?>
 <p:sld xmlns:a="http://schemas.openxmlformats.org/drawingml/2006/main" xmlns:r="http://schemas.openxmlformats.org/officeDocument/2006/relationships" xmlns:p="http://schemas.openxmlformats.org/presentationml/2006/main">
   <p:cSld>
     <p:bg>
@@ -20078,7 +19685,7 @@
 </p:sld>
 </file>
 
-<file path=ppt/slides/slide19.xml><?xml version="1.0" encoding="utf-8"?>
+<file path=ppt/slides/slide18.xml><?xml version="1.0" encoding="utf-8"?>
 <p:sld xmlns:a="http://schemas.openxmlformats.org/drawingml/2006/main" xmlns:r="http://schemas.openxmlformats.org/officeDocument/2006/relationships" xmlns:p="http://schemas.openxmlformats.org/presentationml/2006/main">
   <p:cSld>
     <p:bg>
@@ -20445,67 +20052,7 @@
 </p:sld>
 </file>
 
-<file path=ppt/slides/slide2.xml><?xml version="1.0" encoding="utf-8"?>
-<p:sld xmlns:a="http://schemas.openxmlformats.org/drawingml/2006/main" xmlns:r="http://schemas.openxmlformats.org/officeDocument/2006/relationships" xmlns:p="http://schemas.openxmlformats.org/presentationml/2006/main">
-  <p:cSld>
-    <p:spTree>
-      <p:nvGrpSpPr>
-        <p:cNvPr id="1" name=""/>
-        <p:cNvGrpSpPr/>
-        <p:nvPr/>
-      </p:nvGrpSpPr>
-      <p:grpSpPr>
-        <a:xfrm>
-          <a:off x="0" y="0"/>
-          <a:ext cx="0" cy="0"/>
-          <a:chOff x="0" y="0"/>
-          <a:chExt cx="0" cy="0"/>
-        </a:xfrm>
-      </p:grpSpPr>
-      <p:pic>
-        <p:nvPicPr>
-          <p:cNvPr id="4" name="Picture 3">
-            <a:extLst>
-              <a:ext uri="{FF2B5EF4-FFF2-40B4-BE49-F238E27FC236}">
-                <a16:creationId xmlns:a16="http://schemas.microsoft.com/office/drawing/2014/main" id="{96F2C0D5-15F9-6000-BBBD-1279B705F256}"/>
-              </a:ext>
-            </a:extLst>
-          </p:cNvPr>
-          <p:cNvPicPr>
-            <a:picLocks noChangeAspect="1"/>
-          </p:cNvPicPr>
-          <p:nvPr/>
-        </p:nvPicPr>
-        <p:blipFill>
-          <a:blip r:embed="rId2"/>
-          <a:stretch>
-            <a:fillRect/>
-          </a:stretch>
-        </p:blipFill>
-        <p:spPr>
-          <a:xfrm>
-            <a:off x="1381692" y="0"/>
-            <a:ext cx="9428615" cy="6858000"/>
-          </a:xfrm>
-          <a:prstGeom prst="rect">
-            <a:avLst/>
-          </a:prstGeom>
-        </p:spPr>
-      </p:pic>
-    </p:spTree>
-    <p:extLst>
-      <p:ext uri="{BB962C8B-B14F-4D97-AF65-F5344CB8AC3E}">
-        <p14:creationId xmlns:p14="http://schemas.microsoft.com/office/powerpoint/2010/main" val="3483194011"/>
-      </p:ext>
-    </p:extLst>
-  </p:cSld>
-  <p:clrMapOvr>
-    <a:masterClrMapping/>
-  </p:clrMapOvr>
-</p:sld>
-</file>
-
-<file path=ppt/slides/slide20.xml><?xml version="1.0" encoding="utf-8"?>
+<file path=ppt/slides/slide19.xml><?xml version="1.0" encoding="utf-8"?>
 <p:sld xmlns:a="http://schemas.openxmlformats.org/drawingml/2006/main" xmlns:r="http://schemas.openxmlformats.org/officeDocument/2006/relationships" xmlns:p="http://schemas.openxmlformats.org/presentationml/2006/main">
   <p:cSld>
     <p:bg>
@@ -20922,7 +20469,630 @@
 </p:sld>
 </file>
 
-<file path=ppt/slides/slide21.xml><?xml version="1.0" encoding="utf-8"?>
+<file path=ppt/slides/slide2.xml><?xml version="1.0" encoding="utf-8"?>
+<p:sld xmlns:a="http://schemas.openxmlformats.org/drawingml/2006/main" xmlns:r="http://schemas.openxmlformats.org/officeDocument/2006/relationships" xmlns:p="http://schemas.openxmlformats.org/presentationml/2006/main">
+  <p:cSld>
+    <p:bg>
+      <p:bgPr>
+        <a:solidFill>
+          <a:schemeClr val="lt1"/>
+        </a:solidFill>
+        <a:effectLst/>
+      </p:bgPr>
+    </p:bg>
+    <p:spTree>
+      <p:nvGrpSpPr>
+        <p:cNvPr id="1" name="Shape 135"/>
+        <p:cNvGrpSpPr/>
+        <p:nvPr/>
+      </p:nvGrpSpPr>
+      <p:grpSpPr>
+        <a:xfrm>
+          <a:off x="0" y="0"/>
+          <a:ext cx="0" cy="0"/>
+          <a:chOff x="0" y="0"/>
+          <a:chExt cx="0" cy="0"/>
+        </a:xfrm>
+      </p:grpSpPr>
+      <p:sp>
+        <p:nvSpPr>
+          <p:cNvPr id="137" name="Google Shape;137;p20"/>
+          <p:cNvSpPr/>
+          <p:nvPr/>
+        </p:nvSpPr>
+        <p:spPr>
+          <a:xfrm flipH="1">
+            <a:off x="-1" y="-1"/>
+            <a:ext cx="12191998" cy="1590742"/>
+          </a:xfrm>
+          <a:prstGeom prst="rect">
+            <a:avLst/>
+          </a:prstGeom>
+          <a:gradFill>
+            <a:gsLst>
+              <a:gs pos="0">
+                <a:srgbClr val="000000">
+                  <a:alpha val="95686"/>
+                </a:srgbClr>
+              </a:gs>
+              <a:gs pos="100000">
+                <a:srgbClr val="2F5496"/>
+              </a:gs>
+            </a:gsLst>
+            <a:lin ang="8398416" scaled="0"/>
+          </a:gradFill>
+          <a:ln>
+            <a:noFill/>
+          </a:ln>
+        </p:spPr>
+        <p:txBody>
+          <a:bodyPr spcFirstLastPara="1" wrap="square" lIns="91425" tIns="45700" rIns="91425" bIns="45700" anchor="ctr" anchorCtr="0">
+            <a:noAutofit/>
+          </a:bodyPr>
+          <a:lstStyle/>
+          <a:p>
+            <a:pPr marL="0" marR="0" lvl="0" indent="0" algn="ctr" rtl="0">
+              <a:spcBef>
+                <a:spcPts val="0"/>
+              </a:spcBef>
+              <a:spcAft>
+                <a:spcPts val="0"/>
+              </a:spcAft>
+              <a:buNone/>
+            </a:pPr>
+            <a:endParaRPr sz="1800" b="0" i="0" u="none" strike="noStrike" cap="none">
+              <a:solidFill>
+                <a:schemeClr val="lt1"/>
+              </a:solidFill>
+              <a:latin typeface="Calibri"/>
+              <a:ea typeface="Calibri"/>
+              <a:cs typeface="Calibri"/>
+              <a:sym typeface="Calibri"/>
+            </a:endParaRPr>
+          </a:p>
+        </p:txBody>
+      </p:sp>
+      <p:sp>
+        <p:nvSpPr>
+          <p:cNvPr id="138" name="Google Shape;138;p20"/>
+          <p:cNvSpPr/>
+          <p:nvPr/>
+        </p:nvSpPr>
+        <p:spPr>
+          <a:xfrm rot="10800000" flipH="1">
+            <a:off x="-3" y="142"/>
+            <a:ext cx="8115300" cy="1590600"/>
+          </a:xfrm>
+          <a:prstGeom prst="rect">
+            <a:avLst/>
+          </a:prstGeom>
+          <a:gradFill>
+            <a:gsLst>
+              <a:gs pos="0">
+                <a:srgbClr val="4472C4">
+                  <a:alpha val="0"/>
+                </a:srgbClr>
+              </a:gs>
+              <a:gs pos="20000">
+                <a:srgbClr val="4472C4">
+                  <a:alpha val="0"/>
+                </a:srgbClr>
+              </a:gs>
+              <a:gs pos="100000">
+                <a:srgbClr val="1F3864">
+                  <a:alpha val="54901"/>
+                </a:srgbClr>
+              </a:gs>
+            </a:gsLst>
+            <a:lin ang="13800146" scaled="0"/>
+          </a:gradFill>
+          <a:ln>
+            <a:noFill/>
+          </a:ln>
+        </p:spPr>
+        <p:txBody>
+          <a:bodyPr spcFirstLastPara="1" wrap="square" lIns="91425" tIns="45700" rIns="91425" bIns="45700" anchor="ctr" anchorCtr="0">
+            <a:noAutofit/>
+          </a:bodyPr>
+          <a:lstStyle/>
+          <a:p>
+            <a:pPr marL="0" marR="0" lvl="0" indent="0" algn="ctr" rtl="0">
+              <a:spcBef>
+                <a:spcPts val="0"/>
+              </a:spcBef>
+              <a:spcAft>
+                <a:spcPts val="0"/>
+              </a:spcAft>
+              <a:buNone/>
+            </a:pPr>
+            <a:endParaRPr sz="1800" b="0" i="0" u="none" strike="noStrike" cap="none">
+              <a:solidFill>
+                <a:schemeClr val="lt1"/>
+              </a:solidFill>
+              <a:latin typeface="Calibri"/>
+              <a:ea typeface="Calibri"/>
+              <a:cs typeface="Calibri"/>
+              <a:sym typeface="Calibri"/>
+            </a:endParaRPr>
+          </a:p>
+        </p:txBody>
+      </p:sp>
+      <p:sp>
+        <p:nvSpPr>
+          <p:cNvPr id="139" name="Google Shape;139;p20"/>
+          <p:cNvSpPr txBox="1">
+            <a:spLocks noGrp="1"/>
+          </p:cNvSpPr>
+          <p:nvPr>
+            <p:ph type="title"/>
+          </p:nvPr>
+        </p:nvSpPr>
+        <p:spPr>
+          <a:xfrm>
+            <a:off x="1371599" y="294538"/>
+            <a:ext cx="9895951" cy="1033669"/>
+          </a:xfrm>
+          <a:prstGeom prst="rect">
+            <a:avLst/>
+          </a:prstGeom>
+          <a:noFill/>
+          <a:ln>
+            <a:noFill/>
+          </a:ln>
+        </p:spPr>
+        <p:txBody>
+          <a:bodyPr spcFirstLastPara="1" wrap="square" lIns="91425" tIns="45700" rIns="91425" bIns="45700" anchor="ctr" anchorCtr="0">
+            <a:normAutofit/>
+          </a:bodyPr>
+          <a:lstStyle/>
+          <a:p>
+            <a:pPr marL="0" lvl="0" indent="0" algn="l" rtl="0">
+              <a:lnSpc>
+                <a:spcPct val="90000"/>
+              </a:lnSpc>
+              <a:spcBef>
+                <a:spcPts val="0"/>
+              </a:spcBef>
+              <a:spcAft>
+                <a:spcPts val="0"/>
+              </a:spcAft>
+              <a:buClr>
+                <a:srgbClr val="FFFFFF"/>
+              </a:buClr>
+              <a:buSzPts val="4000"/>
+              <a:buFont typeface="Calibri"/>
+              <a:buNone/>
+            </a:pPr>
+            <a:r>
+              <a:rPr lang="en-US" sz="4000">
+                <a:solidFill>
+                  <a:srgbClr val="FFFFFF"/>
+                </a:solidFill>
+              </a:rPr>
+              <a:t>Tony Wilhelm</a:t>
+            </a:r>
+            <a:endParaRPr/>
+          </a:p>
+        </p:txBody>
+      </p:sp>
+      <p:sp>
+        <p:nvSpPr>
+          <p:cNvPr id="140" name="Google Shape;140;p20"/>
+          <p:cNvSpPr txBox="1">
+            <a:spLocks noGrp="1"/>
+          </p:cNvSpPr>
+          <p:nvPr>
+            <p:ph type="body" idx="1"/>
+          </p:nvPr>
+        </p:nvSpPr>
+        <p:spPr>
+          <a:xfrm>
+            <a:off x="473975" y="1885138"/>
+            <a:ext cx="6272785" cy="3683400"/>
+          </a:xfrm>
+          <a:prstGeom prst="rect">
+            <a:avLst/>
+          </a:prstGeom>
+          <a:noFill/>
+          <a:ln>
+            <a:noFill/>
+          </a:ln>
+        </p:spPr>
+        <p:txBody>
+          <a:bodyPr spcFirstLastPara="1" wrap="square" lIns="91425" tIns="45700" rIns="91425" bIns="45700" anchor="ctr" anchorCtr="0">
+            <a:normAutofit/>
+          </a:bodyPr>
+          <a:lstStyle/>
+          <a:p>
+            <a:pPr marL="0" lvl="0" indent="0" algn="l" rtl="0">
+              <a:lnSpc>
+                <a:spcPct val="90000"/>
+              </a:lnSpc>
+              <a:spcBef>
+                <a:spcPts val="1000"/>
+              </a:spcBef>
+              <a:spcAft>
+                <a:spcPts val="0"/>
+              </a:spcAft>
+              <a:buNone/>
+            </a:pPr>
+            <a:r>
+              <a:rPr lang="en-US" sz="2600" b="0" i="0" u="none" strike="noStrike" dirty="0">
+                <a:latin typeface="+mj-lt"/>
+                <a:ea typeface="Arial"/>
+                <a:cs typeface="Arial"/>
+                <a:sym typeface="Arial"/>
+              </a:rPr>
+              <a:t>Started with Microsoft Access in the 90’s</a:t>
+            </a:r>
+            <a:endParaRPr sz="2600" dirty="0">
+              <a:latin typeface="+mj-lt"/>
+            </a:endParaRPr>
+          </a:p>
+          <a:p>
+            <a:pPr marL="0" lvl="0" indent="0" algn="l" rtl="0">
+              <a:lnSpc>
+                <a:spcPct val="90000"/>
+              </a:lnSpc>
+              <a:spcBef>
+                <a:spcPts val="1000"/>
+              </a:spcBef>
+              <a:spcAft>
+                <a:spcPts val="0"/>
+              </a:spcAft>
+              <a:buNone/>
+            </a:pPr>
+            <a:r>
+              <a:rPr lang="en-US" sz="2600" b="0" i="0" u="none" strike="noStrike" dirty="0">
+                <a:latin typeface="+mj-lt"/>
+                <a:ea typeface="Arial"/>
+                <a:cs typeface="Arial"/>
+                <a:sym typeface="Arial"/>
+              </a:rPr>
+              <a:t>Been using SQL server since 7.0</a:t>
+            </a:r>
+            <a:endParaRPr sz="2600" dirty="0">
+              <a:latin typeface="+mj-lt"/>
+            </a:endParaRPr>
+          </a:p>
+          <a:p>
+            <a:pPr marL="0" lvl="0" indent="0" algn="l" rtl="0">
+              <a:lnSpc>
+                <a:spcPct val="90000"/>
+              </a:lnSpc>
+              <a:spcBef>
+                <a:spcPts val="1000"/>
+              </a:spcBef>
+              <a:spcAft>
+                <a:spcPts val="0"/>
+              </a:spcAft>
+              <a:buNone/>
+            </a:pPr>
+            <a:r>
+              <a:rPr lang="en-US" sz="2600" u="sng" dirty="0">
+                <a:solidFill>
+                  <a:schemeClr val="hlink"/>
+                </a:solidFill>
+                <a:latin typeface="+mj-lt"/>
+                <a:ea typeface="Arial"/>
+                <a:cs typeface="Arial"/>
+                <a:sym typeface="Arial"/>
+                <a:hlinkClick r:id="rId3"/>
+              </a:rPr>
+              <a:t>tonywsql@wilhelm-tech.com</a:t>
+            </a:r>
+            <a:endParaRPr sz="2600" dirty="0">
+              <a:latin typeface="+mj-lt"/>
+              <a:ea typeface="Arial"/>
+              <a:cs typeface="Arial"/>
+              <a:sym typeface="Arial"/>
+            </a:endParaRPr>
+          </a:p>
+          <a:p>
+            <a:pPr marL="0" lvl="0" indent="0" algn="l" rtl="0">
+              <a:lnSpc>
+                <a:spcPct val="90000"/>
+              </a:lnSpc>
+              <a:spcBef>
+                <a:spcPts val="1000"/>
+              </a:spcBef>
+              <a:spcAft>
+                <a:spcPts val="0"/>
+              </a:spcAft>
+              <a:buNone/>
+            </a:pPr>
+            <a:r>
+              <a:rPr lang="en-US" sz="2600" b="0" i="0" u="none" strike="noStrike" dirty="0">
+                <a:latin typeface="+mj-lt"/>
+                <a:ea typeface="Arial"/>
+                <a:cs typeface="Arial"/>
+                <a:sym typeface="Arial"/>
+              </a:rPr>
+              <a:t>     @tonywsql</a:t>
+            </a:r>
+            <a:endParaRPr sz="2600" dirty="0">
+              <a:latin typeface="+mj-lt"/>
+            </a:endParaRPr>
+          </a:p>
+          <a:p>
+            <a:pPr marL="0" lvl="0" indent="0" algn="l" rtl="0">
+              <a:lnSpc>
+                <a:spcPct val="90000"/>
+              </a:lnSpc>
+              <a:spcBef>
+                <a:spcPts val="1000"/>
+              </a:spcBef>
+              <a:spcAft>
+                <a:spcPts val="0"/>
+              </a:spcAft>
+              <a:buNone/>
+            </a:pPr>
+            <a:r>
+              <a:rPr lang="en-US" sz="2600" b="0" i="0" u="none" strike="noStrike" dirty="0">
+                <a:latin typeface="+mj-lt"/>
+                <a:ea typeface="Arial"/>
+                <a:cs typeface="Arial"/>
+                <a:sym typeface="Arial"/>
+              </a:rPr>
+              <a:t>      </a:t>
+            </a:r>
+            <a:r>
+              <a:rPr lang="en-US" sz="2600" b="0" i="0" u="none" strike="noStrike" dirty="0">
+                <a:latin typeface="+mj-lt"/>
+                <a:ea typeface="Arial"/>
+                <a:cs typeface="Arial"/>
+                <a:sym typeface="Arial"/>
+                <a:hlinkClick r:id="rId4"/>
+              </a:rPr>
+              <a:t>https://v-roddba.blogspot.com/</a:t>
+            </a:r>
+            <a:endParaRPr lang="en-US" sz="2600" b="0" i="0" u="none" strike="noStrike" dirty="0">
+              <a:latin typeface="+mj-lt"/>
+              <a:ea typeface="Arial"/>
+              <a:cs typeface="Arial"/>
+              <a:sym typeface="Arial"/>
+            </a:endParaRPr>
+          </a:p>
+          <a:p>
+            <a:pPr marL="0" lvl="0" indent="0" algn="l" rtl="0">
+              <a:lnSpc>
+                <a:spcPct val="90000"/>
+              </a:lnSpc>
+              <a:spcBef>
+                <a:spcPts val="1000"/>
+              </a:spcBef>
+              <a:spcAft>
+                <a:spcPts val="0"/>
+              </a:spcAft>
+              <a:buNone/>
+            </a:pPr>
+            <a:r>
+              <a:rPr lang="en-US" sz="2600" dirty="0">
+                <a:latin typeface="+mj-lt"/>
+              </a:rPr>
+              <a:t>      </a:t>
+            </a:r>
+            <a:r>
+              <a:rPr lang="en-US" sz="2600" dirty="0">
+                <a:latin typeface="+mj-lt"/>
+                <a:hlinkClick r:id="rId5"/>
+              </a:rPr>
+              <a:t>https://github.com/TonyWSQL</a:t>
+            </a:r>
+            <a:endParaRPr sz="2600" dirty="0">
+              <a:latin typeface="+mj-lt"/>
+            </a:endParaRPr>
+          </a:p>
+        </p:txBody>
+      </p:sp>
+      <p:pic>
+        <p:nvPicPr>
+          <p:cNvPr id="141" name="Google Shape;141;p20"/>
+          <p:cNvPicPr preferRelativeResize="0"/>
+          <p:nvPr/>
+        </p:nvPicPr>
+        <p:blipFill>
+          <a:blip r:embed="rId6">
+            <a:alphaModFix/>
+          </a:blip>
+          <a:stretch>
+            <a:fillRect/>
+          </a:stretch>
+        </p:blipFill>
+        <p:spPr>
+          <a:xfrm>
+            <a:off x="6858253" y="1885138"/>
+            <a:ext cx="3683400" cy="3683400"/>
+          </a:xfrm>
+          <a:prstGeom prst="ellipse">
+            <a:avLst/>
+          </a:prstGeom>
+          <a:noFill/>
+          <a:ln>
+            <a:noFill/>
+          </a:ln>
+        </p:spPr>
+      </p:pic>
+      <p:pic>
+        <p:nvPicPr>
+          <p:cNvPr id="1026" name="Picture 2" descr="Twitter logo png, Twitter icon transparent free png 18930745 PNG">
+            <a:extLst>
+              <a:ext uri="{FF2B5EF4-FFF2-40B4-BE49-F238E27FC236}">
+                <a16:creationId xmlns:a16="http://schemas.microsoft.com/office/drawing/2014/main" id="{77A8FF47-810A-F7F2-B2E9-AFB6E362A2BC}"/>
+              </a:ext>
+            </a:extLst>
+          </p:cNvPr>
+          <p:cNvPicPr>
+            <a:picLocks noChangeAspect="1" noChangeArrowheads="1"/>
+          </p:cNvPicPr>
+          <p:nvPr/>
+        </p:nvPicPr>
+        <p:blipFill>
+          <a:blip r:embed="rId7">
+            <a:extLst>
+              <a:ext uri="{28A0092B-C50C-407E-A947-70E740481C1C}">
+                <a14:useLocalDpi xmlns:a14="http://schemas.microsoft.com/office/drawing/2010/main" val="0"/>
+              </a:ext>
+            </a:extLst>
+          </a:blip>
+          <a:srcRect/>
+          <a:stretch>
+            <a:fillRect/>
+          </a:stretch>
+        </p:blipFill>
+        <p:spPr bwMode="auto">
+          <a:xfrm flipH="1">
+            <a:off x="405556" y="3658215"/>
+            <a:ext cx="711723" cy="711723"/>
+          </a:xfrm>
+          <a:prstGeom prst="rect">
+            <a:avLst/>
+          </a:prstGeom>
+          <a:noFill/>
+          <a:extLst>
+            <a:ext uri="{909E8E84-426E-40DD-AFC4-6F175D3DCCD1}">
+              <a14:hiddenFill xmlns:a14="http://schemas.microsoft.com/office/drawing/2010/main">
+                <a:solidFill>
+                  <a:srgbClr val="FFFFFF"/>
+                </a:solidFill>
+              </a14:hiddenFill>
+            </a:ext>
+          </a:extLst>
+        </p:spPr>
+      </p:pic>
+      <p:pic>
+        <p:nvPicPr>
+          <p:cNvPr id="1030" name="Picture 6" descr="GitHub Logos and Usage · GitHub">
+            <a:extLst>
+              <a:ext uri="{FF2B5EF4-FFF2-40B4-BE49-F238E27FC236}">
+                <a16:creationId xmlns:a16="http://schemas.microsoft.com/office/drawing/2014/main" id="{7C9BD6B7-44DA-5C3C-E60A-E46FD371FB12}"/>
+              </a:ext>
+            </a:extLst>
+          </p:cNvPr>
+          <p:cNvPicPr>
+            <a:picLocks noChangeAspect="1" noChangeArrowheads="1"/>
+          </p:cNvPicPr>
+          <p:nvPr/>
+        </p:nvPicPr>
+        <p:blipFill>
+          <a:blip r:embed="rId8">
+            <a:extLst>
+              <a:ext uri="{28A0092B-C50C-407E-A947-70E740481C1C}">
+                <a14:useLocalDpi xmlns:a14="http://schemas.microsoft.com/office/drawing/2010/main" val="0"/>
+              </a:ext>
+            </a:extLst>
+          </a:blip>
+          <a:srcRect/>
+          <a:stretch>
+            <a:fillRect/>
+          </a:stretch>
+        </p:blipFill>
+        <p:spPr bwMode="auto">
+          <a:xfrm>
+            <a:off x="473975" y="4664733"/>
+            <a:ext cx="619125" cy="619125"/>
+          </a:xfrm>
+          <a:prstGeom prst="rect">
+            <a:avLst/>
+          </a:prstGeom>
+          <a:noFill/>
+          <a:extLst>
+            <a:ext uri="{909E8E84-426E-40DD-AFC4-6F175D3DCCD1}">
+              <a14:hiddenFill xmlns:a14="http://schemas.microsoft.com/office/drawing/2010/main">
+                <a:solidFill>
+                  <a:srgbClr val="FFFFFF"/>
+                </a:solidFill>
+              </a14:hiddenFill>
+            </a:ext>
+          </a:extLst>
+        </p:spPr>
+      </p:pic>
+      <p:pic>
+        <p:nvPicPr>
+          <p:cNvPr id="1032" name="Picture 8">
+            <a:extLst>
+              <a:ext uri="{FF2B5EF4-FFF2-40B4-BE49-F238E27FC236}">
+                <a16:creationId xmlns:a16="http://schemas.microsoft.com/office/drawing/2014/main" id="{BF886A15-8696-37A6-4205-45F2E8AB5658}"/>
+              </a:ext>
+            </a:extLst>
+          </p:cNvPr>
+          <p:cNvPicPr>
+            <a:picLocks noChangeAspect="1" noChangeArrowheads="1"/>
+          </p:cNvPicPr>
+          <p:nvPr/>
+        </p:nvPicPr>
+        <p:blipFill>
+          <a:blip r:embed="rId9">
+            <a:extLst>
+              <a:ext uri="{28A0092B-C50C-407E-A947-70E740481C1C}">
+                <a14:useLocalDpi xmlns:a14="http://schemas.microsoft.com/office/drawing/2010/main" val="0"/>
+              </a:ext>
+            </a:extLst>
+          </a:blip>
+          <a:srcRect/>
+          <a:stretch>
+            <a:fillRect/>
+          </a:stretch>
+        </p:blipFill>
+        <p:spPr bwMode="auto">
+          <a:xfrm>
+            <a:off x="570917" y="4266888"/>
+            <a:ext cx="445984" cy="445984"/>
+          </a:xfrm>
+          <a:prstGeom prst="rect">
+            <a:avLst/>
+          </a:prstGeom>
+          <a:noFill/>
+          <a:extLst>
+            <a:ext uri="{909E8E84-426E-40DD-AFC4-6F175D3DCCD1}">
+              <a14:hiddenFill xmlns:a14="http://schemas.microsoft.com/office/drawing/2010/main">
+                <a:solidFill>
+                  <a:srgbClr val="FFFFFF"/>
+                </a:solidFill>
+              </a14:hiddenFill>
+            </a:ext>
+          </a:extLst>
+        </p:spPr>
+      </p:pic>
+      <p:pic>
+        <p:nvPicPr>
+          <p:cNvPr id="3" name="Picture 2">
+            <a:extLst>
+              <a:ext uri="{FF2B5EF4-FFF2-40B4-BE49-F238E27FC236}">
+                <a16:creationId xmlns:a16="http://schemas.microsoft.com/office/drawing/2014/main" id="{231BA57F-A3D9-C256-0007-A0C9EB442804}"/>
+              </a:ext>
+            </a:extLst>
+          </p:cNvPr>
+          <p:cNvPicPr>
+            <a:picLocks noChangeAspect="1"/>
+          </p:cNvPicPr>
+          <p:nvPr/>
+        </p:nvPicPr>
+        <p:blipFill>
+          <a:blip r:embed="rId10"/>
+          <a:stretch>
+            <a:fillRect/>
+          </a:stretch>
+        </p:blipFill>
+        <p:spPr>
+          <a:xfrm>
+            <a:off x="10653146" y="4974295"/>
+            <a:ext cx="1357619" cy="1808564"/>
+          </a:xfrm>
+          <a:prstGeom prst="rect">
+            <a:avLst/>
+          </a:prstGeom>
+        </p:spPr>
+      </p:pic>
+    </p:spTree>
+  </p:cSld>
+  <p:clrMapOvr>
+    <a:masterClrMapping/>
+  </p:clrMapOvr>
+</p:sld>
+</file>
+
+<file path=ppt/slides/slide20.xml><?xml version="1.0" encoding="utf-8"?>
 <p:sld xmlns:a="http://schemas.openxmlformats.org/drawingml/2006/main" xmlns:r="http://schemas.openxmlformats.org/officeDocument/2006/relationships" xmlns:p="http://schemas.openxmlformats.org/presentationml/2006/main">
   <p:cSld>
     <p:bg>
@@ -21357,7 +21527,7 @@
 </p:sld>
 </file>
 
-<file path=ppt/slides/slide22.xml><?xml version="1.0" encoding="utf-8"?>
+<file path=ppt/slides/slide21.xml><?xml version="1.0" encoding="utf-8"?>
 <p:sld xmlns:a="http://schemas.openxmlformats.org/drawingml/2006/main" xmlns:r="http://schemas.openxmlformats.org/officeDocument/2006/relationships" xmlns:p="http://schemas.openxmlformats.org/presentationml/2006/main">
   <p:cSld>
     <p:bg>
@@ -21823,7 +21993,7 @@
 </p:sld>
 </file>
 
-<file path=ppt/slides/slide23.xml><?xml version="1.0" encoding="utf-8"?>
+<file path=ppt/slides/slide22.xml><?xml version="1.0" encoding="utf-8"?>
 <p:sld xmlns:a="http://schemas.openxmlformats.org/drawingml/2006/main" xmlns:r="http://schemas.openxmlformats.org/officeDocument/2006/relationships" xmlns:p="http://schemas.openxmlformats.org/presentationml/2006/main">
   <p:cSld>
     <p:bg>
@@ -22481,7 +22651,7 @@
 </p:sld>
 </file>
 
-<file path=ppt/slides/slide24.xml><?xml version="1.0" encoding="utf-8"?>
+<file path=ppt/slides/slide23.xml><?xml version="1.0" encoding="utf-8"?>
 <p:sld xmlns:a="http://schemas.openxmlformats.org/drawingml/2006/main" xmlns:r="http://schemas.openxmlformats.org/officeDocument/2006/relationships" xmlns:p="http://schemas.openxmlformats.org/presentationml/2006/main">
   <p:cSld>
     <p:bg>
@@ -22953,6 +23123,90 @@
               </a:rPr>
               <a:t>https://dbatools.io/</a:t>
             </a:r>
+            <a:endParaRPr lang="en-US" sz="2000" u="sng" dirty="0">
+              <a:solidFill>
+                <a:schemeClr val="hlink"/>
+              </a:solidFill>
+              <a:latin typeface="Arial"/>
+              <a:ea typeface="Arial"/>
+              <a:cs typeface="Arial"/>
+              <a:sym typeface="Arial"/>
+            </a:endParaRPr>
+          </a:p>
+          <a:p>
+            <a:pPr marL="228600" lvl="0" indent="-228600" algn="l" rtl="0">
+              <a:spcBef>
+                <a:spcPts val="0"/>
+              </a:spcBef>
+              <a:spcAft>
+                <a:spcPts val="0"/>
+              </a:spcAft>
+              <a:buSzPts val="2000"/>
+              <a:buChar char="•"/>
+            </a:pPr>
+            <a:endParaRPr lang="en-US" sz="2000" u="sng" dirty="0">
+              <a:solidFill>
+                <a:schemeClr val="hlink"/>
+              </a:solidFill>
+              <a:latin typeface="Arial"/>
+              <a:ea typeface="Arial"/>
+              <a:cs typeface="Arial"/>
+              <a:sym typeface="Arial"/>
+            </a:endParaRPr>
+          </a:p>
+          <a:p>
+            <a:pPr marL="228600" lvl="0" indent="-228600">
+              <a:spcBef>
+                <a:spcPts val="0"/>
+              </a:spcBef>
+              <a:buSzPts val="2000"/>
+            </a:pPr>
+            <a:r>
+              <a:rPr lang="en-US" sz="2000" dirty="0">
+                <a:latin typeface="Arial"/>
+                <a:cs typeface="Arial"/>
+                <a:sym typeface="Arial"/>
+              </a:rPr>
+              <a:t>Slides and Demos</a:t>
+            </a:r>
+            <a:br>
+              <a:rPr lang="en-US" sz="2000" u="sng" dirty="0">
+                <a:solidFill>
+                  <a:schemeClr val="hlink"/>
+                </a:solidFill>
+                <a:latin typeface="Arial"/>
+                <a:ea typeface="Arial"/>
+                <a:cs typeface="Arial"/>
+                <a:sym typeface="Arial"/>
+              </a:rPr>
+            </a:br>
+            <a:r>
+              <a:rPr lang="en-US" sz="2000" dirty="0">
+                <a:hlinkClick r:id="rId6"/>
+              </a:rPr>
+              <a:t>https://github.com/TonyWSQL</a:t>
+            </a:r>
+            <a:endParaRPr lang="en-US" sz="2000" u="sng" dirty="0">
+              <a:solidFill>
+                <a:schemeClr val="hlink"/>
+              </a:solidFill>
+              <a:latin typeface="Arial"/>
+              <a:ea typeface="Arial"/>
+              <a:cs typeface="Arial"/>
+              <a:sym typeface="Arial"/>
+            </a:endParaRPr>
+          </a:p>
+          <a:p>
+            <a:pPr marL="228600" lvl="0" indent="-228600" algn="l" rtl="0">
+              <a:spcBef>
+                <a:spcPts val="0"/>
+              </a:spcBef>
+              <a:spcAft>
+                <a:spcPts val="0"/>
+              </a:spcAft>
+              <a:buSzPts val="2000"/>
+              <a:buChar char="•"/>
+            </a:pPr>
             <a:endParaRPr sz="2000" dirty="0">
               <a:latin typeface="Arial"/>
               <a:ea typeface="Arial"/>
@@ -22970,7 +23224,7 @@
 </p:sld>
 </file>
 
-<file path=ppt/slides/slide25.xml><?xml version="1.0" encoding="utf-8"?>
+<file path=ppt/slides/slide24.xml><?xml version="1.0" encoding="utf-8"?>
 <p:sld xmlns:a="http://schemas.openxmlformats.org/drawingml/2006/main" xmlns:r="http://schemas.openxmlformats.org/officeDocument/2006/relationships" xmlns:p="http://schemas.openxmlformats.org/presentationml/2006/main">
   <p:cSld>
     <p:bg>
@@ -23299,599 +23553,6 @@
 </file>
 
 <file path=ppt/slides/slide3.xml><?xml version="1.0" encoding="utf-8"?>
-<p:sld xmlns:a="http://schemas.openxmlformats.org/drawingml/2006/main" xmlns:r="http://schemas.openxmlformats.org/officeDocument/2006/relationships" xmlns:p="http://schemas.openxmlformats.org/presentationml/2006/main">
-  <p:cSld>
-    <p:bg>
-      <p:bgPr>
-        <a:solidFill>
-          <a:schemeClr val="lt1"/>
-        </a:solidFill>
-        <a:effectLst/>
-      </p:bgPr>
-    </p:bg>
-    <p:spTree>
-      <p:nvGrpSpPr>
-        <p:cNvPr id="1" name="Shape 135"/>
-        <p:cNvGrpSpPr/>
-        <p:nvPr/>
-      </p:nvGrpSpPr>
-      <p:grpSpPr>
-        <a:xfrm>
-          <a:off x="0" y="0"/>
-          <a:ext cx="0" cy="0"/>
-          <a:chOff x="0" y="0"/>
-          <a:chExt cx="0" cy="0"/>
-        </a:xfrm>
-      </p:grpSpPr>
-      <p:sp>
-        <p:nvSpPr>
-          <p:cNvPr id="137" name="Google Shape;137;p20"/>
-          <p:cNvSpPr/>
-          <p:nvPr/>
-        </p:nvSpPr>
-        <p:spPr>
-          <a:xfrm flipH="1">
-            <a:off x="-1" y="-1"/>
-            <a:ext cx="12191998" cy="1590742"/>
-          </a:xfrm>
-          <a:prstGeom prst="rect">
-            <a:avLst/>
-          </a:prstGeom>
-          <a:gradFill>
-            <a:gsLst>
-              <a:gs pos="0">
-                <a:srgbClr val="000000">
-                  <a:alpha val="95686"/>
-                </a:srgbClr>
-              </a:gs>
-              <a:gs pos="100000">
-                <a:srgbClr val="2F5496"/>
-              </a:gs>
-            </a:gsLst>
-            <a:lin ang="8398416" scaled="0"/>
-          </a:gradFill>
-          <a:ln>
-            <a:noFill/>
-          </a:ln>
-        </p:spPr>
-        <p:txBody>
-          <a:bodyPr spcFirstLastPara="1" wrap="square" lIns="91425" tIns="45700" rIns="91425" bIns="45700" anchor="ctr" anchorCtr="0">
-            <a:noAutofit/>
-          </a:bodyPr>
-          <a:lstStyle/>
-          <a:p>
-            <a:pPr marL="0" marR="0" lvl="0" indent="0" algn="ctr" rtl="0">
-              <a:spcBef>
-                <a:spcPts val="0"/>
-              </a:spcBef>
-              <a:spcAft>
-                <a:spcPts val="0"/>
-              </a:spcAft>
-              <a:buNone/>
-            </a:pPr>
-            <a:endParaRPr sz="1800" b="0" i="0" u="none" strike="noStrike" cap="none">
-              <a:solidFill>
-                <a:schemeClr val="lt1"/>
-              </a:solidFill>
-              <a:latin typeface="Calibri"/>
-              <a:ea typeface="Calibri"/>
-              <a:cs typeface="Calibri"/>
-              <a:sym typeface="Calibri"/>
-            </a:endParaRPr>
-          </a:p>
-        </p:txBody>
-      </p:sp>
-      <p:sp>
-        <p:nvSpPr>
-          <p:cNvPr id="138" name="Google Shape;138;p20"/>
-          <p:cNvSpPr/>
-          <p:nvPr/>
-        </p:nvSpPr>
-        <p:spPr>
-          <a:xfrm rot="10800000" flipH="1">
-            <a:off x="-3" y="142"/>
-            <a:ext cx="8115300" cy="1590600"/>
-          </a:xfrm>
-          <a:prstGeom prst="rect">
-            <a:avLst/>
-          </a:prstGeom>
-          <a:gradFill>
-            <a:gsLst>
-              <a:gs pos="0">
-                <a:srgbClr val="4472C4">
-                  <a:alpha val="0"/>
-                </a:srgbClr>
-              </a:gs>
-              <a:gs pos="20000">
-                <a:srgbClr val="4472C4">
-                  <a:alpha val="0"/>
-                </a:srgbClr>
-              </a:gs>
-              <a:gs pos="100000">
-                <a:srgbClr val="1F3864">
-                  <a:alpha val="54901"/>
-                </a:srgbClr>
-              </a:gs>
-            </a:gsLst>
-            <a:lin ang="13800146" scaled="0"/>
-          </a:gradFill>
-          <a:ln>
-            <a:noFill/>
-          </a:ln>
-        </p:spPr>
-        <p:txBody>
-          <a:bodyPr spcFirstLastPara="1" wrap="square" lIns="91425" tIns="45700" rIns="91425" bIns="45700" anchor="ctr" anchorCtr="0">
-            <a:noAutofit/>
-          </a:bodyPr>
-          <a:lstStyle/>
-          <a:p>
-            <a:pPr marL="0" marR="0" lvl="0" indent="0" algn="ctr" rtl="0">
-              <a:spcBef>
-                <a:spcPts val="0"/>
-              </a:spcBef>
-              <a:spcAft>
-                <a:spcPts val="0"/>
-              </a:spcAft>
-              <a:buNone/>
-            </a:pPr>
-            <a:endParaRPr sz="1800" b="0" i="0" u="none" strike="noStrike" cap="none">
-              <a:solidFill>
-                <a:schemeClr val="lt1"/>
-              </a:solidFill>
-              <a:latin typeface="Calibri"/>
-              <a:ea typeface="Calibri"/>
-              <a:cs typeface="Calibri"/>
-              <a:sym typeface="Calibri"/>
-            </a:endParaRPr>
-          </a:p>
-        </p:txBody>
-      </p:sp>
-      <p:sp>
-        <p:nvSpPr>
-          <p:cNvPr id="139" name="Google Shape;139;p20"/>
-          <p:cNvSpPr txBox="1">
-            <a:spLocks noGrp="1"/>
-          </p:cNvSpPr>
-          <p:nvPr>
-            <p:ph type="title"/>
-          </p:nvPr>
-        </p:nvSpPr>
-        <p:spPr>
-          <a:xfrm>
-            <a:off x="1371599" y="294538"/>
-            <a:ext cx="9895951" cy="1033669"/>
-          </a:xfrm>
-          <a:prstGeom prst="rect">
-            <a:avLst/>
-          </a:prstGeom>
-          <a:noFill/>
-          <a:ln>
-            <a:noFill/>
-          </a:ln>
-        </p:spPr>
-        <p:txBody>
-          <a:bodyPr spcFirstLastPara="1" wrap="square" lIns="91425" tIns="45700" rIns="91425" bIns="45700" anchor="ctr" anchorCtr="0">
-            <a:normAutofit/>
-          </a:bodyPr>
-          <a:lstStyle/>
-          <a:p>
-            <a:pPr marL="0" lvl="0" indent="0" algn="l" rtl="0">
-              <a:lnSpc>
-                <a:spcPct val="90000"/>
-              </a:lnSpc>
-              <a:spcBef>
-                <a:spcPts val="0"/>
-              </a:spcBef>
-              <a:spcAft>
-                <a:spcPts val="0"/>
-              </a:spcAft>
-              <a:buClr>
-                <a:srgbClr val="FFFFFF"/>
-              </a:buClr>
-              <a:buSzPts val="4000"/>
-              <a:buFont typeface="Calibri"/>
-              <a:buNone/>
-            </a:pPr>
-            <a:r>
-              <a:rPr lang="en-US" sz="4000">
-                <a:solidFill>
-                  <a:srgbClr val="FFFFFF"/>
-                </a:solidFill>
-              </a:rPr>
-              <a:t>Tony Wilhelm</a:t>
-            </a:r>
-            <a:endParaRPr/>
-          </a:p>
-        </p:txBody>
-      </p:sp>
-      <p:sp>
-        <p:nvSpPr>
-          <p:cNvPr id="140" name="Google Shape;140;p20"/>
-          <p:cNvSpPr txBox="1">
-            <a:spLocks noGrp="1"/>
-          </p:cNvSpPr>
-          <p:nvPr>
-            <p:ph type="body" idx="1"/>
-          </p:nvPr>
-        </p:nvSpPr>
-        <p:spPr>
-          <a:xfrm>
-            <a:off x="1371599" y="2318197"/>
-            <a:ext cx="9724031" cy="3683358"/>
-          </a:xfrm>
-          <a:prstGeom prst="rect">
-            <a:avLst/>
-          </a:prstGeom>
-          <a:noFill/>
-          <a:ln>
-            <a:noFill/>
-          </a:ln>
-        </p:spPr>
-        <p:txBody>
-          <a:bodyPr spcFirstLastPara="1" wrap="square" lIns="91425" tIns="45700" rIns="91425" bIns="45700" anchor="ctr" anchorCtr="0">
-            <a:normAutofit/>
-          </a:bodyPr>
-          <a:lstStyle/>
-          <a:p>
-            <a:pPr marL="0" lvl="0" indent="0" algn="l" rtl="0">
-              <a:lnSpc>
-                <a:spcPct val="90000"/>
-              </a:lnSpc>
-              <a:spcBef>
-                <a:spcPts val="1000"/>
-              </a:spcBef>
-              <a:spcAft>
-                <a:spcPts val="0"/>
-              </a:spcAft>
-              <a:buNone/>
-            </a:pPr>
-            <a:r>
-              <a:rPr lang="en-US" sz="2600" b="0" i="0" u="none" strike="noStrike" dirty="0">
-                <a:latin typeface="+mj-lt"/>
-                <a:ea typeface="Arial"/>
-                <a:cs typeface="Arial"/>
-                <a:sym typeface="Arial"/>
-              </a:rPr>
-              <a:t>Started with Microsoft Access in the 90’s</a:t>
-            </a:r>
-            <a:endParaRPr sz="2600" dirty="0">
-              <a:latin typeface="+mj-lt"/>
-            </a:endParaRPr>
-          </a:p>
-          <a:p>
-            <a:pPr marL="0" lvl="0" indent="0" algn="l" rtl="0">
-              <a:lnSpc>
-                <a:spcPct val="90000"/>
-              </a:lnSpc>
-              <a:spcBef>
-                <a:spcPts val="1000"/>
-              </a:spcBef>
-              <a:spcAft>
-                <a:spcPts val="0"/>
-              </a:spcAft>
-              <a:buNone/>
-            </a:pPr>
-            <a:r>
-              <a:rPr lang="en-US" sz="2600" b="0" i="0" u="none" strike="noStrike" dirty="0">
-                <a:latin typeface="+mj-lt"/>
-                <a:ea typeface="Arial"/>
-                <a:cs typeface="Arial"/>
-                <a:sym typeface="Arial"/>
-              </a:rPr>
-              <a:t>Been using SQL server since 7.0</a:t>
-            </a:r>
-            <a:endParaRPr sz="2600" dirty="0">
-              <a:latin typeface="+mj-lt"/>
-            </a:endParaRPr>
-          </a:p>
-          <a:p>
-            <a:pPr marL="0" lvl="0" indent="0" algn="l" rtl="0">
-              <a:lnSpc>
-                <a:spcPct val="90000"/>
-              </a:lnSpc>
-              <a:spcBef>
-                <a:spcPts val="1000"/>
-              </a:spcBef>
-              <a:spcAft>
-                <a:spcPts val="0"/>
-              </a:spcAft>
-              <a:buNone/>
-            </a:pPr>
-            <a:r>
-              <a:rPr lang="en-US" sz="2600" u="sng" dirty="0">
-                <a:solidFill>
-                  <a:schemeClr val="hlink"/>
-                </a:solidFill>
-                <a:latin typeface="+mj-lt"/>
-                <a:ea typeface="Arial"/>
-                <a:cs typeface="Arial"/>
-                <a:sym typeface="Arial"/>
-                <a:hlinkClick r:id="rId3"/>
-              </a:rPr>
-              <a:t>tonywsql@wilhelm-tech.com</a:t>
-            </a:r>
-            <a:endParaRPr sz="2600" dirty="0">
-              <a:latin typeface="+mj-lt"/>
-              <a:ea typeface="Arial"/>
-              <a:cs typeface="Arial"/>
-              <a:sym typeface="Arial"/>
-            </a:endParaRPr>
-          </a:p>
-          <a:p>
-            <a:pPr marL="0" lvl="0" indent="0" algn="l" rtl="0">
-              <a:lnSpc>
-                <a:spcPct val="90000"/>
-              </a:lnSpc>
-              <a:spcBef>
-                <a:spcPts val="1000"/>
-              </a:spcBef>
-              <a:spcAft>
-                <a:spcPts val="0"/>
-              </a:spcAft>
-              <a:buNone/>
-            </a:pPr>
-            <a:r>
-              <a:rPr lang="en-US" sz="2600" b="0" i="0" u="none" strike="noStrike" dirty="0">
-                <a:latin typeface="+mj-lt"/>
-                <a:ea typeface="Arial"/>
-                <a:cs typeface="Arial"/>
-                <a:sym typeface="Arial"/>
-              </a:rPr>
-              <a:t>     @tonywsql</a:t>
-            </a:r>
-            <a:endParaRPr sz="2600" dirty="0">
-              <a:latin typeface="+mj-lt"/>
-            </a:endParaRPr>
-          </a:p>
-          <a:p>
-            <a:pPr marL="0" lvl="0" indent="0" algn="l" rtl="0">
-              <a:lnSpc>
-                <a:spcPct val="90000"/>
-              </a:lnSpc>
-              <a:spcBef>
-                <a:spcPts val="1000"/>
-              </a:spcBef>
-              <a:spcAft>
-                <a:spcPts val="0"/>
-              </a:spcAft>
-              <a:buNone/>
-            </a:pPr>
-            <a:r>
-              <a:rPr lang="en-US" sz="2600" b="0" i="0" u="none" strike="noStrike" dirty="0">
-                <a:latin typeface="+mj-lt"/>
-                <a:ea typeface="Arial"/>
-                <a:cs typeface="Arial"/>
-                <a:sym typeface="Arial"/>
-              </a:rPr>
-              <a:t>      </a:t>
-            </a:r>
-            <a:r>
-              <a:rPr lang="en-US" sz="2600" b="0" i="0" u="none" strike="noStrike" dirty="0">
-                <a:latin typeface="+mj-lt"/>
-                <a:ea typeface="Arial"/>
-                <a:cs typeface="Arial"/>
-                <a:sym typeface="Arial"/>
-                <a:hlinkClick r:id="rId4"/>
-              </a:rPr>
-              <a:t>https://v-roddba.blogspot.com/</a:t>
-            </a:r>
-            <a:endParaRPr lang="en-US" sz="2600" b="0" i="0" u="none" strike="noStrike" dirty="0">
-              <a:latin typeface="+mj-lt"/>
-              <a:ea typeface="Arial"/>
-              <a:cs typeface="Arial"/>
-              <a:sym typeface="Arial"/>
-            </a:endParaRPr>
-          </a:p>
-          <a:p>
-            <a:pPr marL="0" lvl="0" indent="0" algn="l" rtl="0">
-              <a:lnSpc>
-                <a:spcPct val="90000"/>
-              </a:lnSpc>
-              <a:spcBef>
-                <a:spcPts val="1000"/>
-              </a:spcBef>
-              <a:spcAft>
-                <a:spcPts val="0"/>
-              </a:spcAft>
-              <a:buNone/>
-            </a:pPr>
-            <a:r>
-              <a:rPr lang="en-US" sz="2600" dirty="0">
-                <a:latin typeface="+mj-lt"/>
-              </a:rPr>
-              <a:t>      </a:t>
-            </a:r>
-            <a:r>
-              <a:rPr lang="en-US" sz="2600" dirty="0">
-                <a:latin typeface="+mj-lt"/>
-                <a:hlinkClick r:id="rId5"/>
-              </a:rPr>
-              <a:t>https://github.com/TonyWSQL</a:t>
-            </a:r>
-            <a:endParaRPr sz="2600" dirty="0">
-              <a:latin typeface="+mj-lt"/>
-            </a:endParaRPr>
-          </a:p>
-        </p:txBody>
-      </p:sp>
-      <p:pic>
-        <p:nvPicPr>
-          <p:cNvPr id="141" name="Google Shape;141;p20"/>
-          <p:cNvPicPr preferRelativeResize="0"/>
-          <p:nvPr/>
-        </p:nvPicPr>
-        <p:blipFill>
-          <a:blip r:embed="rId6">
-            <a:alphaModFix/>
-          </a:blip>
-          <a:stretch>
-            <a:fillRect/>
-          </a:stretch>
-        </p:blipFill>
-        <p:spPr>
-          <a:xfrm>
-            <a:off x="8034625" y="2033475"/>
-            <a:ext cx="3683400" cy="3683400"/>
-          </a:xfrm>
-          <a:prstGeom prst="ellipse">
-            <a:avLst/>
-          </a:prstGeom>
-          <a:noFill/>
-          <a:ln>
-            <a:noFill/>
-          </a:ln>
-        </p:spPr>
-      </p:pic>
-      <p:pic>
-        <p:nvPicPr>
-          <p:cNvPr id="1026" name="Picture 2" descr="Twitter logo png, Twitter icon transparent free png 18930745 PNG">
-            <a:extLst>
-              <a:ext uri="{FF2B5EF4-FFF2-40B4-BE49-F238E27FC236}">
-                <a16:creationId xmlns:a16="http://schemas.microsoft.com/office/drawing/2014/main" id="{77A8FF47-810A-F7F2-B2E9-AFB6E362A2BC}"/>
-              </a:ext>
-            </a:extLst>
-          </p:cNvPr>
-          <p:cNvPicPr>
-            <a:picLocks noChangeAspect="1" noChangeArrowheads="1"/>
-          </p:cNvPicPr>
-          <p:nvPr/>
-        </p:nvPicPr>
-        <p:blipFill>
-          <a:blip r:embed="rId7">
-            <a:extLst>
-              <a:ext uri="{28A0092B-C50C-407E-A947-70E740481C1C}">
-                <a14:useLocalDpi xmlns:a14="http://schemas.microsoft.com/office/drawing/2010/main" val="0"/>
-              </a:ext>
-            </a:extLst>
-          </a:blip>
-          <a:srcRect/>
-          <a:stretch>
-            <a:fillRect/>
-          </a:stretch>
-        </p:blipFill>
-        <p:spPr bwMode="auto">
-          <a:xfrm flipH="1">
-            <a:off x="1303180" y="4091232"/>
-            <a:ext cx="711723" cy="711723"/>
-          </a:xfrm>
-          <a:prstGeom prst="rect">
-            <a:avLst/>
-          </a:prstGeom>
-          <a:noFill/>
-          <a:extLst>
-            <a:ext uri="{909E8E84-426E-40DD-AFC4-6F175D3DCCD1}">
-              <a14:hiddenFill xmlns:a14="http://schemas.microsoft.com/office/drawing/2010/main">
-                <a:solidFill>
-                  <a:srgbClr val="FFFFFF"/>
-                </a:solidFill>
-              </a14:hiddenFill>
-            </a:ext>
-          </a:extLst>
-        </p:spPr>
-      </p:pic>
-      <p:pic>
-        <p:nvPicPr>
-          <p:cNvPr id="1030" name="Picture 6" descr="GitHub Logos and Usage · GitHub">
-            <a:extLst>
-              <a:ext uri="{FF2B5EF4-FFF2-40B4-BE49-F238E27FC236}">
-                <a16:creationId xmlns:a16="http://schemas.microsoft.com/office/drawing/2014/main" id="{7C9BD6B7-44DA-5C3C-E60A-E46FD371FB12}"/>
-              </a:ext>
-            </a:extLst>
-          </p:cNvPr>
-          <p:cNvPicPr>
-            <a:picLocks noChangeAspect="1" noChangeArrowheads="1"/>
-          </p:cNvPicPr>
-          <p:nvPr/>
-        </p:nvPicPr>
-        <p:blipFill>
-          <a:blip r:embed="rId8">
-            <a:extLst>
-              <a:ext uri="{28A0092B-C50C-407E-A947-70E740481C1C}">
-                <a14:useLocalDpi xmlns:a14="http://schemas.microsoft.com/office/drawing/2010/main" val="0"/>
-              </a:ext>
-            </a:extLst>
-          </a:blip>
-          <a:srcRect/>
-          <a:stretch>
-            <a:fillRect/>
-          </a:stretch>
-        </p:blipFill>
-        <p:spPr bwMode="auto">
-          <a:xfrm>
-            <a:off x="1371599" y="5097750"/>
-            <a:ext cx="619125" cy="619125"/>
-          </a:xfrm>
-          <a:prstGeom prst="rect">
-            <a:avLst/>
-          </a:prstGeom>
-          <a:noFill/>
-          <a:extLst>
-            <a:ext uri="{909E8E84-426E-40DD-AFC4-6F175D3DCCD1}">
-              <a14:hiddenFill xmlns:a14="http://schemas.microsoft.com/office/drawing/2010/main">
-                <a:solidFill>
-                  <a:srgbClr val="FFFFFF"/>
-                </a:solidFill>
-              </a14:hiddenFill>
-            </a:ext>
-          </a:extLst>
-        </p:spPr>
-      </p:pic>
-      <p:pic>
-        <p:nvPicPr>
-          <p:cNvPr id="1032" name="Picture 8">
-            <a:extLst>
-              <a:ext uri="{FF2B5EF4-FFF2-40B4-BE49-F238E27FC236}">
-                <a16:creationId xmlns:a16="http://schemas.microsoft.com/office/drawing/2014/main" id="{BF886A15-8696-37A6-4205-45F2E8AB5658}"/>
-              </a:ext>
-            </a:extLst>
-          </p:cNvPr>
-          <p:cNvPicPr>
-            <a:picLocks noChangeAspect="1" noChangeArrowheads="1"/>
-          </p:cNvPicPr>
-          <p:nvPr/>
-        </p:nvPicPr>
-        <p:blipFill>
-          <a:blip r:embed="rId9">
-            <a:extLst>
-              <a:ext uri="{28A0092B-C50C-407E-A947-70E740481C1C}">
-                <a14:useLocalDpi xmlns:a14="http://schemas.microsoft.com/office/drawing/2010/main" val="0"/>
-              </a:ext>
-            </a:extLst>
-          </a:blip>
-          <a:srcRect/>
-          <a:stretch>
-            <a:fillRect/>
-          </a:stretch>
-        </p:blipFill>
-        <p:spPr bwMode="auto">
-          <a:xfrm>
-            <a:off x="1468541" y="4699905"/>
-            <a:ext cx="445984" cy="445984"/>
-          </a:xfrm>
-          <a:prstGeom prst="rect">
-            <a:avLst/>
-          </a:prstGeom>
-          <a:noFill/>
-          <a:extLst>
-            <a:ext uri="{909E8E84-426E-40DD-AFC4-6F175D3DCCD1}">
-              <a14:hiddenFill xmlns:a14="http://schemas.microsoft.com/office/drawing/2010/main">
-                <a:solidFill>
-                  <a:srgbClr val="FFFFFF"/>
-                </a:solidFill>
-              </a14:hiddenFill>
-            </a:ext>
-          </a:extLst>
-        </p:spPr>
-      </p:pic>
-    </p:spTree>
-  </p:cSld>
-  <p:clrMapOvr>
-    <a:masterClrMapping/>
-  </p:clrMapOvr>
-</p:sld>
-</file>
-
-<file path=ppt/slides/slide4.xml><?xml version="1.0" encoding="utf-8"?>
 <p:sld xmlns:a="http://schemas.openxmlformats.org/drawingml/2006/main" xmlns:r="http://schemas.openxmlformats.org/officeDocument/2006/relationships" xmlns:p="http://schemas.openxmlformats.org/presentationml/2006/main">
   <p:cSld>
     <p:bg>
@@ -24465,7 +24126,7 @@
 </p:sld>
 </file>
 
-<file path=ppt/slides/slide5.xml><?xml version="1.0" encoding="utf-8"?>
+<file path=ppt/slides/slide4.xml><?xml version="1.0" encoding="utf-8"?>
 <p:sld xmlns:a="http://schemas.openxmlformats.org/drawingml/2006/main" xmlns:r="http://schemas.openxmlformats.org/officeDocument/2006/relationships" xmlns:p="http://schemas.openxmlformats.org/presentationml/2006/main">
   <p:cSld>
     <p:bg>
@@ -25123,7 +24784,7 @@
 </p:sld>
 </file>
 
-<file path=ppt/slides/slide6.xml><?xml version="1.0" encoding="utf-8"?>
+<file path=ppt/slides/slide5.xml><?xml version="1.0" encoding="utf-8"?>
 <p:sld xmlns:a="http://schemas.openxmlformats.org/drawingml/2006/main" xmlns:r="http://schemas.openxmlformats.org/officeDocument/2006/relationships" xmlns:p="http://schemas.openxmlformats.org/presentationml/2006/main">
   <p:cSld>
     <p:bg>
@@ -25644,7 +25305,7 @@
 </p:sld>
 </file>
 
-<file path=ppt/slides/slide7.xml><?xml version="1.0" encoding="utf-8"?>
+<file path=ppt/slides/slide6.xml><?xml version="1.0" encoding="utf-8"?>
 <p:sld xmlns:a="http://schemas.openxmlformats.org/drawingml/2006/main" xmlns:r="http://schemas.openxmlformats.org/officeDocument/2006/relationships" xmlns:p="http://schemas.openxmlformats.org/presentationml/2006/main">
   <p:cSld>
     <p:bg>
@@ -26959,7 +26620,7 @@
 </p:sld>
 </file>
 
-<file path=ppt/slides/slide8.xml><?xml version="1.0" encoding="utf-8"?>
+<file path=ppt/slides/slide7.xml><?xml version="1.0" encoding="utf-8"?>
 <p:sld xmlns:a="http://schemas.openxmlformats.org/drawingml/2006/main" xmlns:r="http://schemas.openxmlformats.org/officeDocument/2006/relationships" xmlns:p="http://schemas.openxmlformats.org/presentationml/2006/main">
   <p:cSld>
     <p:bg>
@@ -27598,7 +27259,7 @@
 </p:sld>
 </file>
 
-<file path=ppt/slides/slide9.xml><?xml version="1.0" encoding="utf-8"?>
+<file path=ppt/slides/slide8.xml><?xml version="1.0" encoding="utf-8"?>
 <p:sld xmlns:a="http://schemas.openxmlformats.org/drawingml/2006/main" xmlns:r="http://schemas.openxmlformats.org/officeDocument/2006/relationships" xmlns:p="http://schemas.openxmlformats.org/presentationml/2006/main">
   <p:cSld>
     <p:bg>
@@ -28005,6 +27666,460 @@
               <a:buNone/>
             </a:pPr>
             <a:endParaRPr/>
+          </a:p>
+        </p:txBody>
+      </p:sp>
+    </p:spTree>
+  </p:cSld>
+  <p:clrMapOvr>
+    <a:masterClrMapping/>
+  </p:clrMapOvr>
+</p:sld>
+</file>
+
+<file path=ppt/slides/slide9.xml><?xml version="1.0" encoding="utf-8"?>
+<p:sld xmlns:a="http://schemas.openxmlformats.org/drawingml/2006/main" xmlns:r="http://schemas.openxmlformats.org/officeDocument/2006/relationships" xmlns:p="http://schemas.openxmlformats.org/presentationml/2006/main">
+  <p:cSld>
+    <p:bg>
+      <p:bgPr>
+        <a:solidFill>
+          <a:schemeClr val="lt1"/>
+        </a:solidFill>
+        <a:effectLst/>
+      </p:bgPr>
+    </p:bg>
+    <p:spTree>
+      <p:nvGrpSpPr>
+        <p:cNvPr id="1" name="Shape 237"/>
+        <p:cNvGrpSpPr/>
+        <p:nvPr/>
+      </p:nvGrpSpPr>
+      <p:grpSpPr>
+        <a:xfrm>
+          <a:off x="0" y="0"/>
+          <a:ext cx="0" cy="0"/>
+          <a:chOff x="0" y="0"/>
+          <a:chExt cx="0" cy="0"/>
+        </a:xfrm>
+      </p:grpSpPr>
+      <p:sp>
+        <p:nvSpPr>
+          <p:cNvPr id="238" name="Google Shape;238;p10"/>
+          <p:cNvSpPr/>
+          <p:nvPr/>
+        </p:nvSpPr>
+        <p:spPr>
+          <a:xfrm flipH="1">
+            <a:off x="-3" y="-1"/>
+            <a:ext cx="12192000" cy="1590600"/>
+          </a:xfrm>
+          <a:prstGeom prst="rect">
+            <a:avLst/>
+          </a:prstGeom>
+          <a:gradFill>
+            <a:gsLst>
+              <a:gs pos="0">
+                <a:srgbClr val="000000"/>
+              </a:gs>
+              <a:gs pos="100000">
+                <a:srgbClr val="2F5496"/>
+              </a:gs>
+            </a:gsLst>
+            <a:lin ang="8400134" scaled="0"/>
+          </a:gradFill>
+          <a:ln>
+            <a:noFill/>
+          </a:ln>
+        </p:spPr>
+        <p:txBody>
+          <a:bodyPr spcFirstLastPara="1" wrap="square" lIns="91425" tIns="45700" rIns="91425" bIns="45700" anchor="ctr" anchorCtr="0">
+            <a:noAutofit/>
+          </a:bodyPr>
+          <a:lstStyle/>
+          <a:p>
+            <a:pPr marL="0" marR="0" lvl="0" indent="0" algn="ctr" rtl="0">
+              <a:spcBef>
+                <a:spcPts val="0"/>
+              </a:spcBef>
+              <a:spcAft>
+                <a:spcPts val="0"/>
+              </a:spcAft>
+              <a:buNone/>
+            </a:pPr>
+            <a:endParaRPr sz="1800" b="0" i="0" u="none" strike="noStrike" cap="none">
+              <a:solidFill>
+                <a:schemeClr val="lt1"/>
+              </a:solidFill>
+              <a:latin typeface="Calibri"/>
+              <a:ea typeface="Calibri"/>
+              <a:cs typeface="Calibri"/>
+              <a:sym typeface="Calibri"/>
+            </a:endParaRPr>
+          </a:p>
+        </p:txBody>
+      </p:sp>
+      <p:sp>
+        <p:nvSpPr>
+          <p:cNvPr id="239" name="Google Shape;239;p10"/>
+          <p:cNvSpPr/>
+          <p:nvPr/>
+        </p:nvSpPr>
+        <p:spPr>
+          <a:xfrm rot="10800000" flipH="1">
+            <a:off x="-3" y="142"/>
+            <a:ext cx="8115300" cy="1590600"/>
+          </a:xfrm>
+          <a:prstGeom prst="rect">
+            <a:avLst/>
+          </a:prstGeom>
+          <a:gradFill>
+            <a:gsLst>
+              <a:gs pos="0">
+                <a:srgbClr val="4472C4">
+                  <a:alpha val="0"/>
+                </a:srgbClr>
+              </a:gs>
+              <a:gs pos="20000">
+                <a:srgbClr val="4472C4">
+                  <a:alpha val="0"/>
+                </a:srgbClr>
+              </a:gs>
+              <a:gs pos="100000">
+                <a:srgbClr val="1F3864">
+                  <a:alpha val="54901"/>
+                </a:srgbClr>
+              </a:gs>
+            </a:gsLst>
+            <a:lin ang="13800146" scaled="0"/>
+          </a:gradFill>
+          <a:ln>
+            <a:noFill/>
+          </a:ln>
+        </p:spPr>
+        <p:txBody>
+          <a:bodyPr spcFirstLastPara="1" wrap="square" lIns="91425" tIns="45700" rIns="91425" bIns="45700" anchor="ctr" anchorCtr="0">
+            <a:noAutofit/>
+          </a:bodyPr>
+          <a:lstStyle/>
+          <a:p>
+            <a:pPr marL="0" marR="0" lvl="0" indent="0" algn="ctr" rtl="0">
+              <a:spcBef>
+                <a:spcPts val="0"/>
+              </a:spcBef>
+              <a:spcAft>
+                <a:spcPts val="0"/>
+              </a:spcAft>
+              <a:buNone/>
+            </a:pPr>
+            <a:endParaRPr sz="1800" b="0" i="0" u="none" strike="noStrike" cap="none">
+              <a:solidFill>
+                <a:schemeClr val="lt1"/>
+              </a:solidFill>
+              <a:latin typeface="Calibri"/>
+              <a:ea typeface="Calibri"/>
+              <a:cs typeface="Calibri"/>
+              <a:sym typeface="Calibri"/>
+            </a:endParaRPr>
+          </a:p>
+        </p:txBody>
+      </p:sp>
+      <p:sp>
+        <p:nvSpPr>
+          <p:cNvPr id="240" name="Google Shape;240;p10"/>
+          <p:cNvSpPr txBox="1">
+            <a:spLocks noGrp="1"/>
+          </p:cNvSpPr>
+          <p:nvPr>
+            <p:ph type="title"/>
+          </p:nvPr>
+        </p:nvSpPr>
+        <p:spPr>
+          <a:xfrm>
+            <a:off x="1371597" y="348865"/>
+            <a:ext cx="10044000" cy="877800"/>
+          </a:xfrm>
+          <a:prstGeom prst="rect">
+            <a:avLst/>
+          </a:prstGeom>
+          <a:noFill/>
+          <a:ln>
+            <a:noFill/>
+          </a:ln>
+        </p:spPr>
+        <p:txBody>
+          <a:bodyPr spcFirstLastPara="1" wrap="square" lIns="91425" tIns="45700" rIns="91425" bIns="45700" anchor="ctr" anchorCtr="0">
+            <a:normAutofit/>
+          </a:bodyPr>
+          <a:lstStyle/>
+          <a:p>
+            <a:pPr marL="0" lvl="0" indent="0" algn="l" rtl="0">
+              <a:lnSpc>
+                <a:spcPct val="90000"/>
+              </a:lnSpc>
+              <a:spcBef>
+                <a:spcPts val="0"/>
+              </a:spcBef>
+              <a:spcAft>
+                <a:spcPts val="0"/>
+              </a:spcAft>
+              <a:buClr>
+                <a:srgbClr val="FFFFFF"/>
+              </a:buClr>
+              <a:buSzPts val="4000"/>
+              <a:buFont typeface="Calibri"/>
+              <a:buNone/>
+            </a:pPr>
+            <a:r>
+              <a:rPr lang="en-US" sz="4000">
+                <a:solidFill>
+                  <a:srgbClr val="FFFFFF"/>
+                </a:solidFill>
+                <a:latin typeface="Calibri"/>
+                <a:ea typeface="Calibri"/>
+                <a:cs typeface="Calibri"/>
+                <a:sym typeface="Calibri"/>
+              </a:rPr>
+              <a:t>Variables</a:t>
+            </a:r>
+            <a:endParaRPr/>
+          </a:p>
+        </p:txBody>
+      </p:sp>
+      <p:sp>
+        <p:nvSpPr>
+          <p:cNvPr id="241" name="Google Shape;241;p10"/>
+          <p:cNvSpPr txBox="1">
+            <a:spLocks noGrp="1"/>
+          </p:cNvSpPr>
+          <p:nvPr>
+            <p:ph type="body" idx="2"/>
+          </p:nvPr>
+        </p:nvSpPr>
+        <p:spPr>
+          <a:xfrm>
+            <a:off x="1166297" y="2112579"/>
+            <a:ext cx="4872919" cy="4089712"/>
+          </a:xfrm>
+          <a:prstGeom prst="rect">
+            <a:avLst/>
+          </a:prstGeom>
+          <a:noFill/>
+          <a:ln>
+            <a:noFill/>
+          </a:ln>
+        </p:spPr>
+        <p:txBody>
+          <a:bodyPr spcFirstLastPara="1" wrap="square" lIns="91425" tIns="45700" rIns="91425" bIns="45700" anchor="t" anchorCtr="0">
+            <a:normAutofit/>
+          </a:bodyPr>
+          <a:lstStyle/>
+          <a:p>
+            <a:pPr marL="212598" lvl="0" indent="-212343" algn="l" rtl="0">
+              <a:lnSpc>
+                <a:spcPct val="90000"/>
+              </a:lnSpc>
+              <a:spcBef>
+                <a:spcPts val="0"/>
+              </a:spcBef>
+              <a:spcAft>
+                <a:spcPts val="0"/>
+              </a:spcAft>
+              <a:buClr>
+                <a:schemeClr val="dk1"/>
+              </a:buClr>
+              <a:buSzPts val="2600"/>
+              <a:buChar char="•"/>
+            </a:pPr>
+            <a:r>
+              <a:rPr lang="en-US" sz="2600" dirty="0">
+                <a:solidFill>
+                  <a:schemeClr val="dk1"/>
+                </a:solidFill>
+                <a:latin typeface="Calibri"/>
+                <a:ea typeface="Calibri"/>
+                <a:cs typeface="Calibri"/>
+                <a:sym typeface="Calibri"/>
+              </a:rPr>
+              <a:t>Names start with a $</a:t>
+            </a:r>
+            <a:endParaRPr sz="2600" dirty="0"/>
+          </a:p>
+          <a:p>
+            <a:pPr marL="212598" lvl="0" indent="-212343" algn="l" rtl="0">
+              <a:lnSpc>
+                <a:spcPct val="90000"/>
+              </a:lnSpc>
+              <a:spcBef>
+                <a:spcPts val="930"/>
+              </a:spcBef>
+              <a:spcAft>
+                <a:spcPts val="0"/>
+              </a:spcAft>
+              <a:buClr>
+                <a:schemeClr val="dk1"/>
+              </a:buClr>
+              <a:buSzPts val="2600"/>
+              <a:buChar char="•"/>
+            </a:pPr>
+            <a:r>
+              <a:rPr lang="en-US" sz="2600" dirty="0">
+                <a:solidFill>
+                  <a:schemeClr val="dk1"/>
+                </a:solidFill>
+                <a:latin typeface="Calibri"/>
+                <a:ea typeface="Calibri"/>
+                <a:cs typeface="Calibri"/>
+                <a:sym typeface="Calibri"/>
+              </a:rPr>
+              <a:t>Names are not case sensitive</a:t>
+            </a:r>
+            <a:endParaRPr sz="2600" dirty="0"/>
+          </a:p>
+          <a:p>
+            <a:pPr marL="212598" lvl="0" indent="-212343" algn="l" rtl="0">
+              <a:lnSpc>
+                <a:spcPct val="90000"/>
+              </a:lnSpc>
+              <a:spcBef>
+                <a:spcPts val="930"/>
+              </a:spcBef>
+              <a:spcAft>
+                <a:spcPts val="0"/>
+              </a:spcAft>
+              <a:buClr>
+                <a:schemeClr val="dk1"/>
+              </a:buClr>
+              <a:buSzPts val="2600"/>
+              <a:buChar char="•"/>
+            </a:pPr>
+            <a:r>
+              <a:rPr lang="en-US" sz="2600" dirty="0">
+                <a:solidFill>
+                  <a:schemeClr val="dk1"/>
+                </a:solidFill>
+                <a:latin typeface="Calibri"/>
+                <a:ea typeface="Calibri"/>
+                <a:cs typeface="Calibri"/>
+                <a:sym typeface="Calibri"/>
+              </a:rPr>
+              <a:t>Can contain numbers and letters</a:t>
+            </a:r>
+            <a:endParaRPr sz="2600" dirty="0"/>
+          </a:p>
+          <a:p>
+            <a:pPr marL="212598" lvl="0" indent="-212343" algn="l" rtl="0">
+              <a:lnSpc>
+                <a:spcPct val="90000"/>
+              </a:lnSpc>
+              <a:spcBef>
+                <a:spcPts val="930"/>
+              </a:spcBef>
+              <a:spcAft>
+                <a:spcPts val="0"/>
+              </a:spcAft>
+              <a:buClr>
+                <a:schemeClr val="dk1"/>
+              </a:buClr>
+              <a:buSzPts val="2600"/>
+              <a:buChar char="•"/>
+            </a:pPr>
+            <a:r>
+              <a:rPr lang="en-US" sz="2600" dirty="0"/>
+              <a:t>Variables have multiple scopes:</a:t>
+            </a:r>
+            <a:endParaRPr sz="2600" dirty="0"/>
+          </a:p>
+          <a:p>
+            <a:pPr marL="669798" lvl="1" indent="-225298" algn="l" rtl="0">
+              <a:lnSpc>
+                <a:spcPct val="90000"/>
+              </a:lnSpc>
+              <a:spcBef>
+                <a:spcPts val="930"/>
+              </a:spcBef>
+              <a:spcAft>
+                <a:spcPts val="0"/>
+              </a:spcAft>
+              <a:buClr>
+                <a:schemeClr val="dk1"/>
+              </a:buClr>
+              <a:buSzPts val="2600"/>
+              <a:buChar char="•"/>
+            </a:pPr>
+            <a:r>
+              <a:rPr lang="en-US" sz="2600" dirty="0"/>
+              <a:t>Global</a:t>
+            </a:r>
+            <a:endParaRPr sz="2600" dirty="0"/>
+          </a:p>
+          <a:p>
+            <a:pPr marL="669798" lvl="1" indent="-225298" algn="l" rtl="0">
+              <a:lnSpc>
+                <a:spcPct val="90000"/>
+              </a:lnSpc>
+              <a:spcBef>
+                <a:spcPts val="930"/>
+              </a:spcBef>
+              <a:spcAft>
+                <a:spcPts val="0"/>
+              </a:spcAft>
+              <a:buClr>
+                <a:schemeClr val="dk1"/>
+              </a:buClr>
+              <a:buSzPts val="2600"/>
+              <a:buChar char="•"/>
+            </a:pPr>
+            <a:r>
+              <a:rPr lang="en-US" sz="2600" dirty="0"/>
+              <a:t>Local</a:t>
+            </a:r>
+            <a:endParaRPr sz="2600" dirty="0"/>
+          </a:p>
+          <a:p>
+            <a:pPr marL="669798" lvl="1" indent="-225298" algn="l" rtl="0">
+              <a:lnSpc>
+                <a:spcPct val="90000"/>
+              </a:lnSpc>
+              <a:spcBef>
+                <a:spcPts val="930"/>
+              </a:spcBef>
+              <a:spcAft>
+                <a:spcPts val="0"/>
+              </a:spcAft>
+              <a:buClr>
+                <a:schemeClr val="dk1"/>
+              </a:buClr>
+              <a:buSzPts val="2600"/>
+              <a:buChar char="•"/>
+            </a:pPr>
+            <a:r>
+              <a:rPr lang="en-US" sz="2600" dirty="0"/>
+              <a:t>Script</a:t>
+            </a:r>
+            <a:endParaRPr sz="2600" dirty="0"/>
+          </a:p>
+          <a:p>
+            <a:pPr marL="669798" lvl="1" indent="-225298" algn="l" rtl="0">
+              <a:lnSpc>
+                <a:spcPct val="90000"/>
+              </a:lnSpc>
+              <a:spcBef>
+                <a:spcPts val="930"/>
+              </a:spcBef>
+              <a:spcAft>
+                <a:spcPts val="0"/>
+              </a:spcAft>
+              <a:buClr>
+                <a:schemeClr val="dk1"/>
+              </a:buClr>
+              <a:buSzPts val="2600"/>
+              <a:buChar char="•"/>
+            </a:pPr>
+            <a:r>
+              <a:rPr lang="en-US" sz="2600" dirty="0"/>
+              <a:t>Private (not really a scope)</a:t>
+            </a:r>
+            <a:endParaRPr sz="2600" dirty="0"/>
           </a:p>
         </p:txBody>
       </p:sp>

</xml_diff>